<commit_message>
Add the project link to the presentation
</commit_message>
<xml_diff>
--- a/docs/presentation/Liquid_Sloshing_Final_Presentation.pptx
+++ b/docs/presentation/Liquid_Sloshing_Final_Presentation.pptx
@@ -2153,7 +2153,7 @@
           <a:lstStyle/>
           <a:p>
             <a:r>
-              <a:t>Everything we have shown can also be explored interactively in a web browser. The 3D Sloshing Lab replays the real SPH water inside the tilting tank, lets you drive the tank yourself, shows the tank on a truck bed over a bumpy road, and compares the four particle sizes. The interactive report has a live demo where you set the motor torque, kick the water and try to calm it yourself, along with all our results. Both open directly from our presentation folder in any web browser, and need no internet connection.</a:t>
+              <a:t>Everything we have shown can also be explored interactively in a web browser. The 3D Sloshing Lab replays the real SPH water inside the tilting tank, lets you drive the tank yourself, shows the tank on a truck bed over a bumpy road, and compares the four particle sizes. The interactive report has a live demo where you set the motor torque, kick the water and try to calm it yourself, along with all our results. Both open directly from our presentation folder in any web browser, and need no internet connection. The complete project, with all the code, trained models, results and the paper, is on GitHub at the link at the bottom of the slide.</a:t>
             </a:r>
           </a:p>
         </p:txBody>
@@ -27745,7 +27745,7 @@
         <p:spPr>
           <a:xfrm>
             <a:off x="548640" y="2468880"/>
-            <a:ext cx="5440680" cy="2880360"/>
+            <a:ext cx="5440680" cy="2514600"/>
           </a:xfrm>
           <a:prstGeom prst="roundRect">
             <a:avLst>
@@ -27855,7 +27855,7 @@
         </p:nvSpPr>
         <p:spPr>
           <a:xfrm>
-            <a:off x="548640" y="5440680"/>
+            <a:off x="548640" y="5074920"/>
             <a:ext cx="5440680" cy="457200"/>
           </a:xfrm>
           <a:prstGeom prst="rect">
@@ -27890,7 +27890,7 @@
         </p:nvSpPr>
         <p:spPr>
           <a:xfrm>
-            <a:off x="548640" y="5870448"/>
+            <a:off x="548640" y="5486400"/>
             <a:ext cx="5440680" cy="365760"/>
           </a:xfrm>
           <a:prstGeom prst="rect">
@@ -27989,7 +27989,7 @@
         <p:spPr>
           <a:xfrm>
             <a:off x="6172200" y="2468880"/>
-            <a:ext cx="5440680" cy="2880360"/>
+            <a:ext cx="5440680" cy="2514600"/>
           </a:xfrm>
           <a:prstGeom prst="roundRect">
             <a:avLst>
@@ -28099,7 +28099,7 @@
         </p:nvSpPr>
         <p:spPr>
           <a:xfrm>
-            <a:off x="6172200" y="5440680"/>
+            <a:off x="6172200" y="5074920"/>
             <a:ext cx="5440680" cy="457200"/>
           </a:xfrm>
           <a:prstGeom prst="rect">
@@ -28134,7 +28134,7 @@
         </p:nvSpPr>
         <p:spPr>
           <a:xfrm>
-            <a:off x="6172200" y="5870448"/>
+            <a:off x="6172200" y="5486400"/>
             <a:ext cx="5440680" cy="365760"/>
           </a:xfrm>
           <a:prstGeom prst="rect">
@@ -28168,6 +28168,51 @@
       <p:sp>
         <p:nvSpPr>
           <p:cNvPr id="12" name="TextBox 11"/>
+          <p:cNvSpPr txBox="1"/>
+          <p:nvPr/>
+        </p:nvSpPr>
+        <p:spPr>
+          <a:xfrm>
+            <a:off x="548640" y="5897880"/>
+            <a:ext cx="11064240" cy="411480"/>
+          </a:xfrm>
+          <a:prstGeom prst="rect">
+            <a:avLst/>
+          </a:prstGeom>
+          <a:noFill/>
+        </p:spPr>
+        <p:txBody>
+          <a:bodyPr wrap="square">
+            <a:spAutoFit/>
+          </a:bodyPr>
+          <a:lstStyle/>
+          <a:p>
+            <a:pPr algn="ctr"/>
+            <a:r>
+              <a:rPr sz="1400">
+                <a:solidFill>
+                  <a:srgbClr val="2B2B2B"/>
+                </a:solidFill>
+                <a:latin typeface="Calibri"/>
+              </a:rPr>
+              <a:t>Full project (code, models, results, paper): </a:t>
+            </a:r>
+            <a:r>
+              <a:rPr sz="1400" b="1">
+                <a:solidFill>
+                  <a:srgbClr val="1F5F86"/>
+                </a:solidFill>
+                <a:latin typeface="Calibri"/>
+                <a:hlinkClick r:id="rId4"/>
+              </a:rPr>
+              <a:t>https://github.com/RacerRed505/LiquidSloshingRL-Capstone</a:t>
+            </a:r>
+          </a:p>
+        </p:txBody>
+      </p:sp>
+      <p:sp>
+        <p:nvSpPr>
+          <p:cNvPr id="13" name="TextBox 12"/>
           <p:cNvSpPr txBox="1"/>
           <p:nvPr/>
         </p:nvSpPr>
@@ -28206,7 +28251,7 @@
       </p:sp>
       <p:sp>
         <p:nvSpPr>
-          <p:cNvPr id="13" name="TextBox 12"/>
+          <p:cNvPr id="14" name="TextBox 13"/>
           <p:cNvSpPr txBox="1"/>
           <p:nvPr/>
         </p:nvSpPr>
@@ -34323,6 +34368,51 @@
         </p:nvSpPr>
         <p:spPr>
           <a:xfrm>
+            <a:off x="548640" y="4937760"/>
+            <a:ext cx="11064240" cy="457200"/>
+          </a:xfrm>
+          <a:prstGeom prst="rect">
+            <a:avLst/>
+          </a:prstGeom>
+          <a:noFill/>
+        </p:spPr>
+        <p:txBody>
+          <a:bodyPr wrap="square">
+            <a:spAutoFit/>
+          </a:bodyPr>
+          <a:lstStyle/>
+          <a:p>
+            <a:pPr algn="ctr"/>
+            <a:r>
+              <a:rPr sz="1600">
+                <a:solidFill>
+                  <a:srgbClr val="2B2B2B"/>
+                </a:solidFill>
+                <a:latin typeface="Calibri"/>
+              </a:rPr>
+              <a:t>Full project on GitHub: </a:t>
+            </a:r>
+            <a:r>
+              <a:rPr sz="1600" b="1">
+                <a:solidFill>
+                  <a:srgbClr val="1F5F86"/>
+                </a:solidFill>
+                <a:latin typeface="Calibri"/>
+                <a:hlinkClick r:id="rId2"/>
+              </a:rPr>
+              <a:t>https://github.com/RacerRed505/LiquidSloshingRL-Capstone</a:t>
+            </a:r>
+          </a:p>
+        </p:txBody>
+      </p:sp>
+      <p:sp>
+        <p:nvSpPr>
+          <p:cNvPr id="6" name="TextBox 5"/>
+          <p:cNvSpPr txBox="1"/>
+          <p:nvPr/>
+        </p:nvSpPr>
+        <p:spPr>
+          <a:xfrm>
             <a:off x="2926080" y="6428232"/>
             <a:ext cx="6309360" cy="256032"/>
           </a:xfrm>
@@ -34356,7 +34446,7 @@
       </p:sp>
       <p:sp>
         <p:nvSpPr>
-          <p:cNvPr id="6" name="TextBox 5"/>
+          <p:cNvPr id="7" name="TextBox 6"/>
           <p:cNvSpPr txBox="1"/>
           <p:nvPr/>
         </p:nvSpPr>

</xml_diff>

<commit_message>
Update presentation speaker notes
</commit_message>
<xml_diff>
--- a/docs/presentation/Liquid_Sloshing_Final_Presentation.pptx
+++ b/docs/presentation/Liquid_Sloshing_Final_Presentation.pptx
@@ -1873,7 +1873,62 @@
           <a:lstStyle/>
           <a:p>
             <a:r>
-              <a:t>Now the results. The first check is the equivalent of a mesh-independence study in FEA or CFD. In FEA or CFD, the part is split into small pieces called a mesh, and the answer can depend on how small those pieces are. So we make the mesh finer and finer until the answer stops changing; then we know the result comes from the physics, not from our choice of mesh. SPH has no mesh, so here the particle size plays that role. We ran exactly the same tank motion with particles of 10, 5, 3 and 2 millimetres. On the right you can see that the difference between one size and the next is 1.40, then 0.70, then 0.35 millimetres. The change keeps getting smaller as the particles get smaller, which shows that the answer is converging, and our grid convergence index calculation confirms it. The 10 millimetre curve is clearly the odd one out, so it is too coarse for accurate predictions. Coarse particles also under-fill the tank: the initial particle arrangement holds 20 percent less water at 10 millimetres, but only 2.2 percent less at 3 and 2 millimetres.</a:t>
+              <a:t>SAY IN YOUR OWN WORDS</a:t>
+            </a:r>
+          </a:p>
+          <a:p>
+            <a:r>
+              <a:t>• Now the results. Check 1 is like a mesh-independence study in FEA or CFD.</a:t>
+            </a:r>
+          </a:p>
+          <a:p>
+            <a:r>
+              <a:t>• Mesh idea: make the mesh finer until the answer stops changing; then the answer comes from the physics, not the mesh. SPH has no mesh, so we shrink the particles instead.</a:t>
+            </a:r>
+          </a:p>
+          <a:p>
+            <a:r>
+              <a:t>• Same tank motion, run with particles of 10, 5, 3 and 2 mm.</a:t>
+            </a:r>
+          </a:p>
+          <a:p>
+            <a:r>
+              <a:t>• Right graph: the change from one size to the next keeps getting smaller, so the answer is settling (converging). Our GCI calculation confirms it.</a:t>
+            </a:r>
+          </a:p>
+          <a:p>
+            <a:r>
+              <a:t>• The 10 mm curve is the odd one out: too coarse for accurate numbers. Big particles also under-fill the tank.</a:t>
+            </a:r>
+          </a:p>
+          <a:p>
+            <a:r>
+              <a:t>NUMBERS</a:t>
+            </a:r>
+          </a:p>
+          <a:p>
+            <a:r>
+              <a:t>1.40 → 0.70 → 0.35 mm · 10 mm holds 20% less water, 3 and 2 mm only 2.2% less</a:t>
+            </a:r>
+          </a:p>
+          <a:p>
+            <a:r>
+              <a:t>KEY LINE</a:t>
+            </a:r>
+          </a:p>
+          <a:p>
+            <a:r>
+              <a:t>"The answer stops changing as the particles get smaller, so the result comes from the physics, not from our particle size."</a:t>
+            </a:r>
+          </a:p>
+          <a:p>
+            <a:r>
+              <a:t>AVOID</a:t>
+            </a:r>
+          </a:p>
+          <a:p>
+            <a:r>
+              <a:t>Don't say "halves exactly" or "textbook"; say "keeps getting smaller".</a:t>
             </a:r>
           </a:p>
         </p:txBody>
@@ -1943,7 +1998,62 @@
           <a:lstStyle/>
           <a:p>
             <a:r>
-              <a:t>The second check compares SPH with the exact hydrostatic answer. When the tank is tilted slowly and held, the water surface must end up level, and the formula tells us exactly where the water's centre of mass must go. On the left, the error falls steadily as the particles get smaller, to 3.1 percent at 2 millimetres. On the right, the blue SPH curve follows the dashed exact answer almost perfectly, with a correlation of 0.999. The orange Housner pendulum barely moves, with a correlation of only 0.48. This is the pendulum's blind spot: it cannot represent the water re-levelling.</a:t>
+              <a:t>SAY IN YOUR OWN WORDS</a:t>
+            </a:r>
+          </a:p>
+          <a:p>
+            <a:r>
+              <a:t>• Check 2 is a test with a known answer. Tilt the tank slowly and hold it: still water always ends up level.</a:t>
+            </a:r>
+          </a:p>
+          <a:p>
+            <a:r>
+              <a:t>• Because the surface is level, simple geometry gives exactly where the water's centre of mass must go: the hydrostatic answer.</a:t>
+            </a:r>
+          </a:p>
+          <a:p>
+            <a:r>
+              <a:t>• Left graph: the error falls as the particles get smaller.</a:t>
+            </a:r>
+          </a:p>
+          <a:p>
+            <a:r>
+              <a:t>• Right graph: blue SPH follows the dashed exact answer almost perfectly. The orange pendulum barely moves.</a:t>
+            </a:r>
+          </a:p>
+          <a:p>
+            <a:r>
+              <a:t>• That is the pendulum's blind spot: it shows the waves but not the water re-levelling to one side.</a:t>
+            </a:r>
+          </a:p>
+          <a:p>
+            <a:r>
+              <a:t>NUMBERS</a:t>
+            </a:r>
+          </a:p>
+          <a:p>
+            <a:r>
+              <a:t>error 3.1% at 2 mm · correlation SPH 0.999 vs pendulum 0.48 · exact −11.24 mm, extrapolated −11.45 mm ± 6.4% (GCI)</a:t>
+            </a:r>
+          </a:p>
+          <a:p>
+            <a:r>
+              <a:t>KEY LINE</a:t>
+            </a:r>
+          </a:p>
+          <a:p>
+            <a:r>
+              <a:t>"The pendulum gets the rhythm but not the lean."</a:t>
+            </a:r>
+          </a:p>
+          <a:p>
+            <a:r>
+              <a:t>AVOID</a:t>
+            </a:r>
+          </a:p>
+          <a:p>
+            <a:r>
+              <a:t>"Follows almost perfectly" is about the shape. The size is still 3.1% off; don't call it exact.</a:t>
             </a:r>
           </a:p>
         </p:txBody>
@@ -2013,7 +2123,57 @@
           <a:lstStyle/>
           <a:p>
             <a:r>
-              <a:t>The third check is the sloshing frequency. We tilted the tank smoothly to 8.6 degrees, held it, and let the water oscillate freely. The SPH water oscillated at 1.422 hertz, within 4.2 percent of potential theory and 5.9 percent of the Housner formula, so the frequency is right. Two differences stand out. First, the SPH wave dies out far too quickly, with a damping ratio of 0.087 against about 0.005 for real water, because coarse particles add numerical damping. Second, the shape differs: the real water shifts downhill and stays there, while the pendulum just oscillates about zero.</a:t>
+              <a:t>SAY IN YOUR OWN WORDS</a:t>
+            </a:r>
+          </a:p>
+          <a:p>
+            <a:r>
+              <a:t>• Check 3: the water's natural rhythm, like a playground swing.</a:t>
+            </a:r>
+          </a:p>
+          <a:p>
+            <a:r>
+              <a:t>• Tilt the tank smoothly to 8.6°, hold it still, and let the water swing on its own. Count the swings.</a:t>
+            </a:r>
+          </a:p>
+          <a:p>
+            <a:r>
+              <a:t>• The frequency matches theory and the Housner formula, so the rhythm is right.</a:t>
+            </a:r>
+          </a:p>
+          <a:p>
+            <a:r>
+              <a:t>• Two differences: the swings die out too fast (coarse particles act like extra friction, a numerical effect), and real water shifts downhill while the pendulum swings about zero.</a:t>
+            </a:r>
+          </a:p>
+          <a:p>
+            <a:r>
+              <a:t>NUMBERS</a:t>
+            </a:r>
+          </a:p>
+          <a:p>
+            <a:r>
+              <a:t>1.422 Hz · +4.2% vs potential theory (1.364 Hz) · +5.9% vs Housner (1.343 Hz) · damping 0.087 vs about 0.005 for real water</a:t>
+            </a:r>
+          </a:p>
+          <a:p>
+            <a:r>
+              <a:t>KEY LINE</a:t>
+            </a:r>
+          </a:p>
+          <a:p>
+            <a:r>
+              <a:t>"The frequency is right; the damping is too high because of the coarse particles."</a:t>
+            </a:r>
+          </a:p>
+          <a:p>
+            <a:r>
+              <a:t>AVOID</a:t>
+            </a:r>
+          </a:p>
+          <a:p>
+            <a:r>
+              <a:t>Say the frequency is validated, not the whole sloshing behaviour.</a:t>
             </a:r>
           </a:p>
         </p:txBody>
@@ -2083,7 +2243,72 @@
           <a:lstStyle/>
           <a:p>
             <a:r>
-              <a:t>Now the real test: each controller drives the motor and the SPH water pushes back on the tank, which is full fluid-structure interaction. A safety check stops a run if the tank spins faster than 1 radian per second. For the learning controller we tested all 25 saved versions and used the best one. PID kept the tank within limits for the whole six seconds, but left 0.0157 joules of sloshing energy. LQR, whose gains were designed on the pendulum model, failed after only 34 steps. This is a direct consequence of the blind spot we just saw: the pendulum model cannot see the re-levelling of the water, so the gains are wrong for real water. The learning controller left only 0.001 joules, about 15 times less than PID, with similar torque and motor energy, but it tripped the safety limit after about five seconds. Scaled to a 2 metre tanker compartment, times grow by the square root of 5, so this window corresponds to about 11 seconds at full scale.</a:t>
+              <a:t>SAY IN YOUR OWN WORDS</a:t>
+            </a:r>
+          </a:p>
+          <a:p>
+            <a:r>
+              <a:t>• Now the real test: the controller drives the motor live and the water pushes back on the tank (full fluid-structure interaction).</a:t>
+            </a:r>
+          </a:p>
+          <a:p>
+            <a:r>
+              <a:t>• Same small kick and the same torque limit for all three. A safety stop ends the run if the tank spins faster than 1 rad/s.</a:t>
+            </a:r>
+          </a:p>
+          <a:p>
+            <a:r>
+              <a:t>• For the learning controller we tested all 25 saved versions and used the best one.</a:t>
+            </a:r>
+          </a:p>
+          <a:p>
+            <a:r>
+              <a:t>• PID: stays in control the whole time, but leaves the most sloshing.</a:t>
+            </a:r>
+          </a:p>
+          <a:p>
+            <a:r>
+              <a:t>• LQR: designed on the pendulum model, so it fails fast. The blind spot from Check 2 makes its gains wrong for real water.</a:t>
+            </a:r>
+          </a:p>
+          <a:p>
+            <a:r>
+              <a:t>• PPO: calms the water far better for similar motor effort, but trips the safety stop at about 5 s.</a:t>
+            </a:r>
+          </a:p>
+          <a:p>
+            <a:r>
+              <a:t>• At 2 m tanker scale, times grow by √5, so 5 s is about 11 s.</a:t>
+            </a:r>
+          </a:p>
+          <a:p>
+            <a:r>
+              <a:t>NUMBERS</a:t>
+            </a:r>
+          </a:p>
+          <a:p>
+            <a:r>
+              <a:t>300 steps = 6 s · torque limit 7 N·m · PID 300 steps, 0.0157 J · LQR 34 steps (0.7 s) · PPO 252 steps, 0.0010 J (15× less than PID) · best version 514560</a:t>
+            </a:r>
+          </a:p>
+          <a:p>
+            <a:r>
+              <a:t>KEY LINE</a:t>
+            </a:r>
+          </a:p>
+          <a:p>
+            <a:r>
+              <a:t>"The learning controller calms realistic water best, but it is stable for about five seconds, and we report that as a known limit."</a:t>
+            </a:r>
+          </a:p>
+          <a:p>
+            <a:r>
+              <a:t>AVOID</a:t>
+            </a:r>
+          </a:p>
+          <a:p>
+            <a:r>
+              <a:t>Don't say PPO "solved" the problem or is "stable".</a:t>
             </a:r>
           </a:p>
         </p:txBody>
@@ -2153,7 +2378,52 @@
           <a:lstStyle/>
           <a:p>
             <a:r>
-              <a:t>Everything we have shown can also be explored interactively in a web browser. The 3D Sloshing Lab replays the real SPH water inside the tilting tank, lets you drive the tank yourself, shows the tank on a truck bed over a bumpy road, and compares the four particle sizes. The interactive report has a live demo where you set the motor torque, kick the water and try to calm it yourself, along with all our results. Both open directly from our presentation folder in any web browser, and need no internet connection. The complete project, with all the code, trained models, results and the paper, is on GitHub at the link at the bottom of the slide.</a:t>
+              <a:t>SAY IN YOUR OWN WORDS</a:t>
+            </a:r>
+          </a:p>
+          <a:p>
+            <a:r>
+              <a:t>• Everything shown can also be explored in a web browser.</a:t>
+            </a:r>
+          </a:p>
+          <a:p>
+            <a:r>
+              <a:t>• 3D Sloshing Lab: a replay of the real SPH water, drive the tank yourself, the tank on a truck over a bumpy road, and the four particle sizes compared.</a:t>
+            </a:r>
+          </a:p>
+          <a:p>
+            <a:r>
+              <a:t>• Interactive report: set the motor torque, kick the water and try to calm it yourself, plus all our results.</a:t>
+            </a:r>
+          </a:p>
+          <a:p>
+            <a:r>
+              <a:t>• Both open from our presentation folder with no internet.</a:t>
+            </a:r>
+          </a:p>
+          <a:p>
+            <a:r>
+              <a:t>• The complete project (code, models, results, paper) is on GitHub at the link at the bottom.</a:t>
+            </a:r>
+          </a:p>
+          <a:p>
+            <a:r>
+              <a:t>KEY LINE</a:t>
+            </a:r>
+          </a:p>
+          <a:p>
+            <a:r>
+              <a:t>"You can try calming the water yourself in the live demo."</a:t>
+            </a:r>
+          </a:p>
+          <a:p>
+            <a:r>
+              <a:t>AVOID</a:t>
+            </a:r>
+          </a:p>
+          <a:p>
+            <a:r>
+              <a:t>The live tab runs the fast pendulum model, not real SPH (SPH is far too slow for a browser).</a:t>
             </a:r>
           </a:p>
         </p:txBody>
@@ -2223,7 +2493,52 @@
           <a:lstStyle/>
           <a:p>
             <a:r>
-              <a:t>We faced several real engineering challenges. The first was simply hardware: the SPH solver needs an NVIDIA graphics card, which our laptop did not have. The first solver crash was a classic stability limit: the time step was too large compared with how fast pressure waves travel through the particles, similar to the Courant condition in CFD. A safety check that ran only every 20 milliseconds was too coarse, because the blow-up developed within one step. The 5 millimetre run crashed until we scaled the wall thickness and time step together. Finally, nine-hour runs on a shared computer needed regular saving.</a:t>
+              <a:t>SAY IN YOUR OWN WORDS (one line each)</a:t>
+            </a:r>
+          </a:p>
+          <a:p>
+            <a:r>
+              <a:t>• Hardware: SPH needs an NVIDIA card and our laptop had none. We rehearsed on Colab, then built the solver on an RTX 5060 and a college RTX 3090.</a:t>
+            </a:r>
+          </a:p>
+          <a:p>
+            <a:r>
+              <a:t>• Solver crashed at once: the time step was too big, like the Courant (CFL) condition in CFD. We split each 20 ms step into about 200 tiny steps.</a:t>
+            </a:r>
+          </a:p>
+          <a:p>
+            <a:r>
+              <a:t>• Crash despite a safety check: the check ran every 20 ms, but the blow-up happened inside one step. We now check after every tiny step.</a:t>
+            </a:r>
+          </a:p>
+          <a:p>
+            <a:r>
+              <a:t>• 5 mm run crashed at step 100: the wall was only 4 particles thick, so it got thinner as the particles shrank. We scaled the wall layers and the time step together.</a:t>
+            </a:r>
+          </a:p>
+          <a:p>
+            <a:r>
+              <a:t>• 9-hour runs on a shared computer: we save every 25 steps and skip finished runs.</a:t>
+            </a:r>
+          </a:p>
+          <a:p>
+            <a:r>
+              <a:t>NUMBERS</a:t>
+            </a:r>
+          </a:p>
+          <a:p>
+            <a:r>
+              <a:t>tiny step about 0.1 ms · 2 mm run about 9 h for 6 s of motion</a:t>
+            </a:r>
+          </a:p>
+          <a:p>
+            <a:r>
+              <a:t>AVOID</a:t>
+            </a:r>
+          </a:p>
+          <a:p>
+            <a:r>
+              <a:t>Saving does not let an SPH run continue mid-way. Say "we don't lose finished runs", not "we can resume".</a:t>
             </a:r>
           </a:p>
         </p:txBody>
@@ -2363,7 +2678,52 @@
           <a:lstStyle/>
           <a:p>
             <a:r>
-              <a:t>The review asked for the outputs to be easier to understand, so here are our results in plain words. First, the detailed water simulation can be trusted: as we make it finer, it settles on the exact textbook answer. Second, the quick model gets the rhythm of the sloshing right but not the lean of the water when the tank is held tilted. Third, a controller designed only on that quick model fails on real water. Fourth, the learning controller calms real water best, but only for about five seconds. And fifth, training cheaply and then checking briefly on detailed physics is an effective way to work.</a:t>
+              <a:t>SAY IN YOUR OWN WORDS (one line each, then move on)</a:t>
+            </a:r>
+          </a:p>
+          <a:p>
+            <a:r>
+              <a:t>1. The detailed water simulation can be trusted (within about 3% of the exact answer).</a:t>
+            </a:r>
+          </a:p>
+          <a:p>
+            <a:r>
+              <a:t>2. The quick model gets the rhythm right, but not the lean.</a:t>
+            </a:r>
+          </a:p>
+          <a:p>
+            <a:r>
+              <a:t>3. A controller designed only on the quick model fails on real water.</a:t>
+            </a:r>
+          </a:p>
+          <a:p>
+            <a:r>
+              <a:t>4. The learning controller calms real water best, for about 5 seconds.</a:t>
+            </a:r>
+          </a:p>
+          <a:p>
+            <a:r>
+              <a:t>5. Cheap training plus a short check on detailed physics works.</a:t>
+            </a:r>
+          </a:p>
+          <a:p>
+            <a:r>
+              <a:t>NUMBERS</a:t>
+            </a:r>
+          </a:p>
+          <a:p>
+            <a:r>
+              <a:t>within 6% · LQR fails in 0.7 s · 15× less than PID · 50,000 extra steps gave a 3.8× better score</a:t>
+            </a:r>
+          </a:p>
+          <a:p>
+            <a:r>
+              <a:t>AVOID</a:t>
+            </a:r>
+          </a:p>
+          <a:p>
+            <a:r>
+              <a:t>Point 5's "detailed physics" means the full multibody tank model, not SPH water.</a:t>
             </a:r>
           </a:p>
         </p:txBody>
@@ -2433,7 +2793,52 @@
           <a:lstStyle/>
           <a:p>
             <a:r>
-              <a:t>What is the significance of these results? First, learning control works on realistic water, not only on the model it was trained on. Second, a classic model-based controller can fail when its model is too simple, which is a warning for anyone designing on equivalent models. Third, we have a practical recipe: train cheaply, fine-tune briefly on realistic physics, and stop early. Fourth, we now know where the cheap model can be trusted. Fifth, for our main application, a road tanker, this gives a route to an active tilting cradle: design and train it on the cheap model, check it on detailed fluid, and only then build it.</a:t>
+              <a:t>SAY IN YOUR OWN WORDS</a:t>
+            </a:r>
+          </a:p>
+          <a:p>
+            <a:r>
+              <a:t>• Learning control works on realistic water, not only on the model it was trained on.</a:t>
+            </a:r>
+          </a:p>
+          <a:p>
+            <a:r>
+              <a:t>• A classic controller can fail when its model is too simple: a warning for anyone designing on equivalent models.</a:t>
+            </a:r>
+          </a:p>
+          <a:p>
+            <a:r>
+              <a:t>• A practical recipe: train cheaply, fine-tune briefly on realistic physics, and stop early.</a:t>
+            </a:r>
+          </a:p>
+          <a:p>
+            <a:r>
+              <a:t>• We now know where the cheap model can be trusted.</a:t>
+            </a:r>
+          </a:p>
+          <a:p>
+            <a:r>
+              <a:t>• For the road tanker: an active tilting cradle could be designed and trained on the cheap model and checked on detailed fluid before anything is built.</a:t>
+            </a:r>
+          </a:p>
+          <a:p>
+            <a:r>
+              <a:t>KEY LINE</a:t>
+            </a:r>
+          </a:p>
+          <a:p>
+            <a:r>
+              <a:t>"Design it cheaply, check it on realistic water, and only then build it."</a:t>
+            </a:r>
+          </a:p>
+          <a:p>
+            <a:r>
+              <a:t>AVOID</a:t>
+            </a:r>
+          </a:p>
+          <a:p>
+            <a:r>
+              <a:t>The tanker cradle is a proposed route, not something we built or proved.</a:t>
             </a:r>
           </a:p>
         </p:txBody>
@@ -2503,7 +2908,57 @@
           <a:lstStyle/>
           <a:p>
             <a:r>
-              <a:t>To conclude, here are our three questions, answered. First, the detailed SPH simulation is accurate for the slow response: it converges steadily and comes within 3.1 percent of the exact answer. Second, the fast pendulum model gets the sloshing frequency right, within 6 percent, but misses the water re-levelling, which dominates when a controller tilts the tank slowly. Third, on real water, the LQR designed on that pendulum fails, PID is stable but leaves more sloshing, and the learning controller leaves about 15 times less sloshing but is stable for only about five seconds.</a:t>
+              <a:t>SAY IN YOUR OWN WORDS</a:t>
+            </a:r>
+          </a:p>
+          <a:p>
+            <a:r>
+              <a:t>• At the start we asked three questions; here are the answers.</a:t>
+            </a:r>
+          </a:p>
+          <a:p>
+            <a:r>
+              <a:t>• 1: the detailed SPH is accurate for the slow response: it converges and lands close to the exact answer.</a:t>
+            </a:r>
+          </a:p>
+          <a:p>
+            <a:r>
+              <a:t>• 2: the fast pendulum gets the sloshing frequency right but misses the water re-levelling, which matters when a controller tilts the tank slowly.</a:t>
+            </a:r>
+          </a:p>
+          <a:p>
+            <a:r>
+              <a:t>• 3: on real water, LQR fails, PID is stable but sloppier, and PPO leaves far less sloshing but for about 5 seconds.</a:t>
+            </a:r>
+          </a:p>
+          <a:p>
+            <a:r>
+              <a:t>NUMBERS</a:t>
+            </a:r>
+          </a:p>
+          <a:p>
+            <a:r>
+              <a:t>3.1% · GCI 6.4% · within 6% · 15× less · about 5 s</a:t>
+            </a:r>
+          </a:p>
+          <a:p>
+            <a:r>
+              <a:t>KEY LINE</a:t>
+            </a:r>
+          </a:p>
+          <a:p>
+            <a:r>
+              <a:t>"Three questions, three answers."</a:t>
+            </a:r>
+          </a:p>
+          <a:p>
+            <a:r>
+              <a:t>AVOID</a:t>
+            </a:r>
+          </a:p>
+          <a:p>
+            <a:r>
+              <a:t>"Accurate" means verified against exact answers, not validated by experiment.</a:t>
             </a:r>
           </a:p>
         </p:txBody>
@@ -2573,7 +3028,42 @@
           <a:lstStyle/>
           <a:p>
             <a:r>
-              <a:t>We also state our limitations openly. This is a simulation study, verified against exact answers but not yet validated by experiment. We extracted bulk quantities, not wall pressures. The damping at 10 millimetres is mostly numerical, and real viscosity, surface tension and air are not modelled. On the control side, the two-way runs were done only at the coarse 10 millimetre size, with one run per controller, the learning controller is stable for only about five seconds, and the controllers read the water's position directly, which a real tank cannot easily measure.</a:t>
+              <a:t>SAY IN YOUR OWN WORDS (say it confidently, not apologetically)</a:t>
+            </a:r>
+          </a:p>
+          <a:p>
+            <a:r>
+              <a:t>• This is a simulation study, verified against exact answers but not yet validated by experiment.</a:t>
+            </a:r>
+          </a:p>
+          <a:p>
+            <a:r>
+              <a:t>• We measured bulk quantities (centre of mass, energy), not wall pressures.</a:t>
+            </a:r>
+          </a:p>
+          <a:p>
+            <a:r>
+              <a:t>• Damping at 10 mm is mostly numerical; real viscosity, surface tension and air are not modelled.</a:t>
+            </a:r>
+          </a:p>
+          <a:p>
+            <a:r>
+              <a:t>• The two-way control runs used the coarse 10 mm size, with one run per controller.</a:t>
+            </a:r>
+          </a:p>
+          <a:p>
+            <a:r>
+              <a:t>• The learning controller is stable for about 5 s, and it reads the water's position directly, which a real tank can't easily measure.</a:t>
+            </a:r>
+          </a:p>
+          <a:p>
+            <a:r>
+              <a:t>KEY LINE</a:t>
+            </a:r>
+          </a:p>
+          <a:p>
+            <a:r>
+              <a:t>"Each of these is addressed in our future scope."</a:t>
             </a:r>
           </a:p>
         </p:txBody>
@@ -2643,7 +3133,42 @@
           <a:lstStyle/>
           <a:p>
             <a:r>
-              <a:t>For future work, the first priority is a physical rig of the same size, to validate the simulation with measured wall pressures and surface heights, and then a larger test towards a real tanker compartment. Second, repeat the free-sloshing test at finer particle sizes to separate real from numerical damping. Third, give the simple pendulum model the missing hydrostatic tilt term and redesign the LQR on it. Fourth, repeat the control tests at a finer resolution with more runs. And finally, move towards hardware by using wall-pressure sensors instead of the water's position.</a:t>
+              <a:t>SAY IN YOUR OWN WORDS</a:t>
+            </a:r>
+          </a:p>
+          <a:p>
+            <a:r>
+              <a:t>• First priority: a physical acrylic rig of the same size, measuring wall pressure and surface height, then scaling up towards a tanker compartment.</a:t>
+            </a:r>
+          </a:p>
+          <a:p>
+            <a:r>
+              <a:t>• Repeat free sloshing at 5, 3 and 2 mm to separate real damping from numerical damping.</a:t>
+            </a:r>
+          </a:p>
+          <a:p>
+            <a:r>
+              <a:t>• Add the missing hydrostatic tilt term to the pendulum and redesign LQR on it.</a:t>
+            </a:r>
+          </a:p>
+          <a:p>
+            <a:r>
+              <a:t>• Stronger control tests: finer particles, several runs per controller, better walls.</a:t>
+            </a:r>
+          </a:p>
+          <a:p>
+            <a:r>
+              <a:t>• Hardware-ready control: use wall-pressure sensors instead of the water's exact position (a first version was tried).</a:t>
+            </a:r>
+          </a:p>
+          <a:p>
+            <a:r>
+              <a:t>KEY LINE</a:t>
+            </a:r>
+          </a:p>
+          <a:p>
+            <a:r>
+              <a:t>"Each limitation has a matching next step."</a:t>
             </a:r>
           </a:p>
         </p:txBody>
@@ -2713,7 +3238,17 @@
           <a:lstStyle/>
           <a:p>
             <a:r>
-              <a:t>These are the key references; the full list of 35 is in our report.</a:t>
+              <a:t>SAY</a:t>
+            </a:r>
+          </a:p>
+          <a:p>
+            <a:r>
+              <a:t>• These are the key references; the full list of 35 is in our report.</a:t>
+            </a:r>
+          </a:p>
+          <a:p>
+            <a:r>
+              <a:t>• Then move to the last slide; this takes about 10 seconds.</a:t>
             </a:r>
           </a:p>
         </p:txBody>
@@ -2783,7 +3318,17 @@
           <a:lstStyle/>
           <a:p>
             <a:r>
-              <a:t>Thank you for your attention. We would be happy to answer any questions.</a:t>
+              <a:t>SAY</a:t>
+            </a:r>
+          </a:p>
+          <a:p>
+            <a:r>
+              <a:t>• Thank you for your attention. We would be happy to answer any questions.</a:t>
+            </a:r>
+          </a:p>
+          <a:p>
+            <a:r>
+              <a:t>• Keep this slide up during questions: it has the GitHub link to the full project.</a:t>
             </a:r>
           </a:p>
         </p:txBody>

</xml_diff>

<commit_message>
Link the hand-calculation workbook from the presentation
</commit_message>
<xml_diff>
--- a/docs/presentation/Liquid_Sloshing_Final_Presentation.pptx
+++ b/docs/presentation/Liquid_Sloshing_Final_Presentation.pptx
@@ -17856,7 +17856,7 @@
         </p:nvGraphicFramePr>
         <p:xfrm>
           <a:off x="548640" y="2103120"/>
-          <a:ext cx="11064240" cy="4114800"/>
+          <a:ext cx="11064240" cy="3785616"/>
         </p:xfrm>
         <a:graphic>
           <a:graphicData uri="http://schemas.openxmlformats.org/drawingml/2006/table">
@@ -17870,7 +17870,7 @@
                 <a:gridCol w="3017520"/>
                 <a:gridCol w="1463040"/>
               </a:tblGrid>
-              <a:tr h="457200">
+              <a:tr h="420624">
                 <a:tc>
                   <a:txBody>
                     <a:bodyPr wrap="square"/>
@@ -18040,7 +18040,7 @@
                   </a:tcPr>
                 </a:tc>
               </a:tr>
-              <a:tr h="457200">
+              <a:tr h="420624">
                 <a:tc>
                   <a:txBody>
                     <a:bodyPr wrap="square"/>
@@ -18210,7 +18210,7 @@
                   </a:tcPr>
                 </a:tc>
               </a:tr>
-              <a:tr h="457200">
+              <a:tr h="420624">
                 <a:tc>
                   <a:txBody>
                     <a:bodyPr wrap="square"/>
@@ -18380,7 +18380,7 @@
                   </a:tcPr>
                 </a:tc>
               </a:tr>
-              <a:tr h="457200">
+              <a:tr h="420624">
                 <a:tc>
                   <a:txBody>
                     <a:bodyPr wrap="square"/>
@@ -18550,7 +18550,7 @@
                   </a:tcPr>
                 </a:tc>
               </a:tr>
-              <a:tr h="457200">
+              <a:tr h="420624">
                 <a:tc>
                   <a:txBody>
                     <a:bodyPr wrap="square"/>
@@ -18720,7 +18720,7 @@
                   </a:tcPr>
                 </a:tc>
               </a:tr>
-              <a:tr h="457200">
+              <a:tr h="420624">
                 <a:tc>
                   <a:txBody>
                     <a:bodyPr wrap="square"/>
@@ -18890,7 +18890,7 @@
                   </a:tcPr>
                 </a:tc>
               </a:tr>
-              <a:tr h="457200">
+              <a:tr h="420624">
                 <a:tc>
                   <a:txBody>
                     <a:bodyPr wrap="square"/>
@@ -19060,7 +19060,7 @@
                   </a:tcPr>
                 </a:tc>
               </a:tr>
-              <a:tr h="457200">
+              <a:tr h="420624">
                 <a:tc>
                   <a:txBody>
                     <a:bodyPr wrap="square"/>
@@ -19230,7 +19230,7 @@
                   </a:tcPr>
                 </a:tc>
               </a:tr>
-              <a:tr h="457200">
+              <a:tr h="420624">
                 <a:tc>
                   <a:txBody>
                     <a:bodyPr wrap="square"/>
@@ -19412,6 +19412,50 @@
         </p:nvSpPr>
         <p:spPr>
           <a:xfrm>
+            <a:off x="548640" y="5943600"/>
+            <a:ext cx="11064240" cy="365760"/>
+          </a:xfrm>
+          <a:prstGeom prst="rect">
+            <a:avLst/>
+          </a:prstGeom>
+          <a:noFill/>
+        </p:spPr>
+        <p:txBody>
+          <a:bodyPr wrap="square">
+            <a:spAutoFit/>
+          </a:bodyPr>
+          <a:lstStyle/>
+          <a:p>
+            <a:r>
+              <a:rPr sz="1400">
+                <a:solidFill>
+                  <a:srgbClr val="2B2B2B"/>
+                </a:solidFill>
+                <a:latin typeface="Calibri"/>
+              </a:rPr>
+              <a:t>Open the workbook: </a:t>
+            </a:r>
+            <a:r>
+              <a:rPr sz="1400" b="1">
+                <a:solidFill>
+                  <a:srgbClr val="1F5F86"/>
+                </a:solidFill>
+                <a:latin typeface="Calibri"/>
+                <a:hlinkClick r:id="rId2"/>
+              </a:rPr>
+              <a:t>Calculation_vs_Simulation.xlsx</a:t>
+            </a:r>
+          </a:p>
+        </p:txBody>
+      </p:sp>
+      <p:sp>
+        <p:nvSpPr>
+          <p:cNvPr id="7" name="TextBox 6"/>
+          <p:cNvSpPr txBox="1"/>
+          <p:nvPr/>
+        </p:nvSpPr>
+        <p:spPr>
+          <a:xfrm>
             <a:off x="2926080" y="6428232"/>
             <a:ext cx="6309360" cy="256032"/>
           </a:xfrm>
@@ -19445,7 +19489,7 @@
       </p:sp>
       <p:sp>
         <p:nvSpPr>
-          <p:cNvPr id="7" name="TextBox 6"/>
+          <p:cNvPr id="8" name="TextBox 7"/>
           <p:cNvSpPr txBox="1"/>
           <p:nvPr/>
         </p:nvSpPr>

</xml_diff>

<commit_message>
Restore full speaker notes
</commit_message>
<xml_diff>
--- a/docs/presentation/Liquid_Sloshing_Final_Presentation.pptx
+++ b/docs/presentation/Liquid_Sloshing_Final_Presentation.pptx
@@ -1873,72 +1873,7 @@
           <a:lstStyle/>
           <a:p>
             <a:r>
-              <a:t>IN ONE SENTENCE</a:t>
-            </a:r>
-          </a:p>
-          <a:p>
-            <a:r>
-              <a:t>We made the particles smaller and smaller, the answer stopped changing much, so the result doesn't depend on our choice of particle size, except at 10 mm, which is too coarse.</a:t>
-            </a:r>
-          </a:p>
-          <a:p>
-            <a:r>
-              <a:t>SAY IN YOUR OWN WORDS</a:t>
-            </a:r>
-          </a:p>
-          <a:p>
-            <a:r>
-              <a:t>• Now the results. Check 1 is like a mesh-independence study in FEA or CFD.</a:t>
-            </a:r>
-          </a:p>
-          <a:p>
-            <a:r>
-              <a:t>• Mesh idea: make the mesh finer until the answer stops changing; then the answer comes from the physics, not the mesh. SPH has no mesh, so we shrink the particles instead.</a:t>
-            </a:r>
-          </a:p>
-          <a:p>
-            <a:r>
-              <a:t>• Same tank motion, run with particles of 10, 5, 3 and 2 mm. (Like drawing water with marbles: smaller marbles, truer shape.)</a:t>
-            </a:r>
-          </a:p>
-          <a:p>
-            <a:r>
-              <a:t>• Right graph: the change from one size to the next keeps getting smaller, so the answer is settling (converging). Our GCI calculation confirms it.</a:t>
-            </a:r>
-          </a:p>
-          <a:p>
-            <a:r>
-              <a:t>• The 10 mm curve is the odd one out: too coarse for accurate numbers. Big particles also under-fill the tank.</a:t>
-            </a:r>
-          </a:p>
-          <a:p>
-            <a:r>
-              <a:t>NUMBERS</a:t>
-            </a:r>
-          </a:p>
-          <a:p>
-            <a:r>
-              <a:t>1.40 → 0.70 → 0.35 mm · 10 mm holds 20% less water, 3 and 2 mm only 2.2% less</a:t>
-            </a:r>
-          </a:p>
-          <a:p>
-            <a:r>
-              <a:t>KEY LINE</a:t>
-            </a:r>
-          </a:p>
-          <a:p>
-            <a:r>
-              <a:t>"The answer stops changing as the particles get smaller, so the result comes from the physics, not from our particle size."</a:t>
-            </a:r>
-          </a:p>
-          <a:p>
-            <a:r>
-              <a:t>AVOID</a:t>
-            </a:r>
-          </a:p>
-          <a:p>
-            <a:r>
-              <a:t>Don't say "halves exactly" or "textbook"; say "keeps getting smaller".</a:t>
+              <a:t>Now the results. The first check is the equivalent of a mesh-independence study in FEA or CFD. In FEA or CFD, the part is split into small pieces called a mesh, and the answer can depend on how small those pieces are. So we make the mesh finer and finer until the answer stops changing; then we know the result comes from the physics, not from our choice of mesh. SPH has no mesh, so here the particle size plays that role. We ran exactly the same tank motion with particles of 10, 5, 3 and 2 millimetres. On the right you can see that the difference between one size and the next is 1.40, then 0.70, then 0.35 millimetres. The change keeps getting smaller as the particles get smaller, which shows that the answer is converging, and our grid convergence index calculation confirms it. The 10 millimetre curve is clearly the odd one out, so it is too coarse for accurate predictions. Coarse particles also under-fill the tank: the initial particle arrangement holds 20 percent less water at 10 millimetres, but only 2.2 percent less at 3 and 2 millimetres.</a:t>
             </a:r>
           </a:p>
         </p:txBody>
@@ -2008,72 +1943,7 @@
           <a:lstStyle/>
           <a:p>
             <a:r>
-              <a:t>IN ONE SENTENCE</a:t>
-            </a:r>
-          </a:p>
-          <a:p>
-            <a:r>
-              <a:t>We gave the simulation a test with a known answer; it got within 3.1% at the finest size and closer as the particles got smaller, while the simple pendulum model got it badly wrong.</a:t>
-            </a:r>
-          </a:p>
-          <a:p>
-            <a:r>
-              <a:t>SAY IN YOUR OWN WORDS</a:t>
-            </a:r>
-          </a:p>
-          <a:p>
-            <a:r>
-              <a:t>• Check 2 is a test with a known answer. Tilt the tank slowly and hold it: still water always ends up level.</a:t>
-            </a:r>
-          </a:p>
-          <a:p>
-            <a:r>
-              <a:t>• Because the surface is level, simple geometry gives exactly where the water's centre of mass must go: the hydrostatic answer.</a:t>
-            </a:r>
-          </a:p>
-          <a:p>
-            <a:r>
-              <a:t>• Left graph: the error falls as the particles get smaller.</a:t>
-            </a:r>
-          </a:p>
-          <a:p>
-            <a:r>
-              <a:t>• Right graph: blue SPH follows the dashed exact answer almost perfectly. The orange pendulum barely moves.</a:t>
-            </a:r>
-          </a:p>
-          <a:p>
-            <a:r>
-              <a:t>• That is the pendulum's blind spot: it shows the waves but not the water re-levelling to one side.</a:t>
-            </a:r>
-          </a:p>
-          <a:p>
-            <a:r>
-              <a:t>NUMBERS</a:t>
-            </a:r>
-          </a:p>
-          <a:p>
-            <a:r>
-              <a:t>error 3.1% at 2 mm · correlation SPH 0.999 vs pendulum 0.48 · exact −11.24 mm, extrapolated −11.45 mm ± 6.4% (GCI)</a:t>
-            </a:r>
-          </a:p>
-          <a:p>
-            <a:r>
-              <a:t>KEY LINE</a:t>
-            </a:r>
-          </a:p>
-          <a:p>
-            <a:r>
-              <a:t>"The pendulum gets the rhythm but not the lean."</a:t>
-            </a:r>
-          </a:p>
-          <a:p>
-            <a:r>
-              <a:t>AVOID</a:t>
-            </a:r>
-          </a:p>
-          <a:p>
-            <a:r>
-              <a:t>"Follows almost perfectly" is about the shape. The size is still 3.1% off; don't call it exact.</a:t>
+              <a:t>The second check compares SPH with the exact hydrostatic answer. When the tank is tilted slowly and held, the water surface must end up level, and the formula tells us exactly where the water's centre of mass must go. On the left, the error falls steadily as the particles get smaller, to 3.1 percent at 2 millimetres. On the right, the blue SPH curve follows the dashed exact answer almost perfectly, with a correlation of 0.999. The orange Housner pendulum barely moves, with a correlation of only 0.48. This is the pendulum's blind spot: it cannot represent the water re-levelling.</a:t>
             </a:r>
           </a:p>
         </p:txBody>
@@ -2143,67 +2013,7 @@
           <a:lstStyle/>
           <a:p>
             <a:r>
-              <a:t>IN ONE SENTENCE</a:t>
-            </a:r>
-          </a:p>
-          <a:p>
-            <a:r>
-              <a:t>We tipped the tank and let the water slosh freely. The simulation got the sloshing rhythm right to within about 5%, but the swings die out too quickly because the particles were coarse.</a:t>
-            </a:r>
-          </a:p>
-          <a:p>
-            <a:r>
-              <a:t>SAY IN YOUR OWN WORDS</a:t>
-            </a:r>
-          </a:p>
-          <a:p>
-            <a:r>
-              <a:t>• Check 3: the water's natural rhythm, like a playground swing.</a:t>
-            </a:r>
-          </a:p>
-          <a:p>
-            <a:r>
-              <a:t>• Tilt the tank smoothly to 8.6°, hold it still, and let the water swing on its own. Count the swings.</a:t>
-            </a:r>
-          </a:p>
-          <a:p>
-            <a:r>
-              <a:t>• The frequency matches theory and the Housner formula, so the rhythm is right.</a:t>
-            </a:r>
-          </a:p>
-          <a:p>
-            <a:r>
-              <a:t>• Two differences: the swings die out too fast (coarse particles act like extra friction, a numerical effect), and real water shifts downhill while the pendulum swings about zero.</a:t>
-            </a:r>
-          </a:p>
-          <a:p>
-            <a:r>
-              <a:t>NUMBERS</a:t>
-            </a:r>
-          </a:p>
-          <a:p>
-            <a:r>
-              <a:t>1.422 Hz · +4.2% vs potential theory (1.364 Hz) · +5.9% vs Housner (1.343 Hz) · damping 0.087 vs about 0.005 for real water</a:t>
-            </a:r>
-          </a:p>
-          <a:p>
-            <a:r>
-              <a:t>KEY LINE</a:t>
-            </a:r>
-          </a:p>
-          <a:p>
-            <a:r>
-              <a:t>"The frequency is right; the damping is too high because of the coarse particles."</a:t>
-            </a:r>
-          </a:p>
-          <a:p>
-            <a:r>
-              <a:t>AVOID</a:t>
-            </a:r>
-          </a:p>
-          <a:p>
-            <a:r>
-              <a:t>Say the frequency is validated, not the whole sloshing behaviour.</a:t>
+              <a:t>The third check is the sloshing frequency. We tilted the tank smoothly to 8.6 degrees, held it, and let the water oscillate freely. The SPH water oscillated at 1.422 hertz, within 4.2 percent of potential theory and 5.9 percent of the Housner formula, so the frequency is right. Two differences stand out. First, the SPH wave dies out far too quickly, with a damping ratio of 0.087 against about 0.005 for real water, because coarse particles add numerical damping. Second, the shape differs: the real water shifts downhill and stays there, while the pendulum just oscillates about zero.</a:t>
             </a:r>
           </a:p>
         </p:txBody>
@@ -2273,82 +2083,7 @@
           <a:lstStyle/>
           <a:p>
             <a:r>
-              <a:t>IN ONE SENTENCE</a:t>
-            </a:r>
-          </a:p>
-          <a:p>
-            <a:r>
-              <a:t>When the water could push back, the learning controller calmed it 15 times better than PID but only stayed stable for about 5 seconds; PID was steady but sloppier; LQR failed because its simple model was wrong.</a:t>
-            </a:r>
-          </a:p>
-          <a:p>
-            <a:r>
-              <a:t>SAY IN YOUR OWN WORDS</a:t>
-            </a:r>
-          </a:p>
-          <a:p>
-            <a:r>
-              <a:t>• Now the real test: the controller drives the motor live and the water pushes back on the tank (full fluid-structure interaction). Like carrying a tray of water while walking: when the water sloshes, it pulls your arms.</a:t>
-            </a:r>
-          </a:p>
-          <a:p>
-            <a:r>
-              <a:t>• Same small kick and the same torque limit for all three. A safety stop ends the run if the tank spins faster than 1 rad/s.</a:t>
-            </a:r>
-          </a:p>
-          <a:p>
-            <a:r>
-              <a:t>• For the learning controller we tested all 25 saved versions and used the best one.</a:t>
-            </a:r>
-          </a:p>
-          <a:p>
-            <a:r>
-              <a:t>• PID: stays in control the whole time, but leaves the most sloshing.</a:t>
-            </a:r>
-          </a:p>
-          <a:p>
-            <a:r>
-              <a:t>• LQR: designed on the pendulum model, so it fails fast. The blind spot from Check 2 makes its gains wrong for real water.</a:t>
-            </a:r>
-          </a:p>
-          <a:p>
-            <a:r>
-              <a:t>• PPO: calms the water far better for similar motor effort, but trips the safety stop at about 5 s.</a:t>
-            </a:r>
-          </a:p>
-          <a:p>
-            <a:r>
-              <a:t>• At 2 m tanker scale, times grow by √5, so 5 s is about 11 s.</a:t>
-            </a:r>
-          </a:p>
-          <a:p>
-            <a:r>
-              <a:t>NUMBERS</a:t>
-            </a:r>
-          </a:p>
-          <a:p>
-            <a:r>
-              <a:t>300 steps = 6 s · torque limit 7 N·m · PID 300 steps, 0.0157 J · LQR 34 steps (0.7 s) · PPO 252 steps, 0.0010 J (15× less than PID) · best version 514560</a:t>
-            </a:r>
-          </a:p>
-          <a:p>
-            <a:r>
-              <a:t>KEY LINE</a:t>
-            </a:r>
-          </a:p>
-          <a:p>
-            <a:r>
-              <a:t>"The learning controller calms realistic water best, but it is stable for about five seconds, and we report that as a known limit."</a:t>
-            </a:r>
-          </a:p>
-          <a:p>
-            <a:r>
-              <a:t>AVOID</a:t>
-            </a:r>
-          </a:p>
-          <a:p>
-            <a:r>
-              <a:t>Don't say PPO "solved" the problem or is "stable".</a:t>
+              <a:t>Now the real test: each controller drives the motor and the SPH water pushes back on the tank, which is full fluid-structure interaction. A safety check stops a run if the tank spins faster than 1 radian per second. For the learning controller we tested all 25 saved versions and used the best one. PID kept the tank within limits for the whole six seconds, but left 0.0157 joules of sloshing energy. LQR, whose gains were designed on the pendulum model, failed after only 34 steps. This is a direct consequence of the blind spot we just saw: the pendulum model cannot see the re-levelling of the water, so the gains are wrong for real water. The learning controller left only 0.001 joules, about 15 times less than PID, with similar torque and motor energy, but it tripped the safety limit after about five seconds. Scaled to a 2 metre tanker compartment, times grow by the square root of 5, so this window corresponds to about 11 seconds at full scale.</a:t>
             </a:r>
           </a:p>
         </p:txBody>
@@ -2418,62 +2153,7 @@
           <a:lstStyle/>
           <a:p>
             <a:r>
-              <a:t>IN ONE SENTENCE</a:t>
-            </a:r>
-          </a:p>
-          <a:p>
-            <a:r>
-              <a:t>Everything we showed can be opened and played with in a web browser, including a live demo where you try to calm the water yourself.</a:t>
-            </a:r>
-          </a:p>
-          <a:p>
-            <a:r>
-              <a:t>SAY IN YOUR OWN WORDS</a:t>
-            </a:r>
-          </a:p>
-          <a:p>
-            <a:r>
-              <a:t>• Everything shown can also be explored in a web browser.</a:t>
-            </a:r>
-          </a:p>
-          <a:p>
-            <a:r>
-              <a:t>• 3D Sloshing Lab: a replay of the real SPH water, drive the tank yourself, the tank on a truck over a bumpy road, and the four particle sizes compared.</a:t>
-            </a:r>
-          </a:p>
-          <a:p>
-            <a:r>
-              <a:t>• Interactive report: set the motor torque, kick the water and try to calm it yourself, plus all our results.</a:t>
-            </a:r>
-          </a:p>
-          <a:p>
-            <a:r>
-              <a:t>• Both open from our presentation folder with no internet.</a:t>
-            </a:r>
-          </a:p>
-          <a:p>
-            <a:r>
-              <a:t>• The complete project (code, models, results, paper) is on GitHub at the link at the bottom.</a:t>
-            </a:r>
-          </a:p>
-          <a:p>
-            <a:r>
-              <a:t>KEY LINE</a:t>
-            </a:r>
-          </a:p>
-          <a:p>
-            <a:r>
-              <a:t>"You can try calming the water yourself in the live demo."</a:t>
-            </a:r>
-          </a:p>
-          <a:p>
-            <a:r>
-              <a:t>AVOID</a:t>
-            </a:r>
-          </a:p>
-          <a:p>
-            <a:r>
-              <a:t>The live tab runs the fast pendulum model, not real SPH (SPH is far too slow for a browser).</a:t>
+              <a:t>Everything we have shown can also be explored interactively in a web browser. The 3D Sloshing Lab replays the real SPH water inside the tilting tank, lets you drive the tank yourself, shows the tank on a truck bed over a bumpy road, and compares the four particle sizes. The interactive report has a live demo where you set the motor torque, kick the water and try to calm it yourself, along with all our results. Both open directly from our presentation folder in any web browser, and need no internet connection. The complete project, with all the code, trained models, results and the paper, is on GitHub at the link at the bottom of the slide.</a:t>
             </a:r>
           </a:p>
         </p:txBody>
@@ -2543,62 +2223,7 @@
           <a:lstStyle/>
           <a:p>
             <a:r>
-              <a:t>IN ONE SENTENCE</a:t>
-            </a:r>
-          </a:p>
-          <a:p>
-            <a:r>
-              <a:t>No suitable graphics card, a solver that blew up from steps that were too big, a safety check that was too slow, thin walls that leaked at fine resolution, and long runs that could be interrupted; we fixed each one.</a:t>
-            </a:r>
-          </a:p>
-          <a:p>
-            <a:r>
-              <a:t>SAY IN YOUR OWN WORDS (one line each)</a:t>
-            </a:r>
-          </a:p>
-          <a:p>
-            <a:r>
-              <a:t>• Hardware: SPH needs an NVIDIA card and our laptop had none (the game wouldn't run on our computer, so we borrowed better ones). We rehearsed on Colab, then built the solver on an RTX 5060 and a college RTX 3090.</a:t>
-            </a:r>
-          </a:p>
-          <a:p>
-            <a:r>
-              <a:t>• Solver crashed at once: the time step was too big, like the Courant (CFL) condition in CFD. We split each 20 ms step into about 200 tiny steps (take the stairs one step at a time).</a:t>
-            </a:r>
-          </a:p>
-          <a:p>
-            <a:r>
-              <a:t>• Crash despite a safety check: the check ran every 20 ms, but the blow-up happened inside one step. We now check after every tiny step (a lifeguard who never looks away).</a:t>
-            </a:r>
-          </a:p>
-          <a:p>
-            <a:r>
-              <a:t>• 5 mm run crashed at step 100: the wall was only 4 particles thick, so it got thinner as the particles shrank. We scaled the wall layers and the time step together (smaller bricks need more rows).</a:t>
-            </a:r>
-          </a:p>
-          <a:p>
-            <a:r>
-              <a:t>• 9-hour runs on a shared computer: we save every 25 steps and skip finished runs.</a:t>
-            </a:r>
-          </a:p>
-          <a:p>
-            <a:r>
-              <a:t>NUMBERS</a:t>
-            </a:r>
-          </a:p>
-          <a:p>
-            <a:r>
-              <a:t>tiny step about 0.1 ms · 2 mm run about 9 h for 6 s of motion</a:t>
-            </a:r>
-          </a:p>
-          <a:p>
-            <a:r>
-              <a:t>AVOID</a:t>
-            </a:r>
-          </a:p>
-          <a:p>
-            <a:r>
-              <a:t>Saving does not let an SPH run continue mid-way. Say "we don't lose finished runs", not "we can resume".</a:t>
+              <a:t>We faced several real engineering challenges. The first was simply hardware: the SPH solver needs an NVIDIA graphics card, which our laptop did not have. The first solver crash was a classic stability limit: the time step was too large compared with how fast pressure waves travel through the particles, similar to the Courant condition in CFD. A safety check that ran only every 20 milliseconds was too coarse, because the blow-up developed within one step. The 5 millimetre run crashed until we scaled the wall thickness and time step together. Finally, nine-hour runs on a shared computer needed regular saving.</a:t>
             </a:r>
           </a:p>
         </p:txBody>
@@ -2738,62 +2363,7 @@
           <a:lstStyle/>
           <a:p>
             <a:r>
-              <a:t>IN ONE SENTENCE</a:t>
-            </a:r>
-          </a:p>
-          <a:p>
-            <a:r>
-              <a:t>The detailed simulation is trustworthy; the simple model gets rhythm but misses the lean; designs based only on it fail; learning control works best for a few seconds; and cheap training plus a short detailed check is a good way to work.</a:t>
-            </a:r>
-          </a:p>
-          <a:p>
-            <a:r>
-              <a:t>SAY IN YOUR OWN WORDS (one line each, then move on)</a:t>
-            </a:r>
-          </a:p>
-          <a:p>
-            <a:r>
-              <a:t>1. The detailed water simulation can be trusted (within about 3% of the exact answer).</a:t>
-            </a:r>
-          </a:p>
-          <a:p>
-            <a:r>
-              <a:t>2. The quick model gets the rhythm right, but not the lean.</a:t>
-            </a:r>
-          </a:p>
-          <a:p>
-            <a:r>
-              <a:t>3. A controller designed only on the quick model fails on real water.</a:t>
-            </a:r>
-          </a:p>
-          <a:p>
-            <a:r>
-              <a:t>4. The learning controller calms real water best, for about 5 seconds.</a:t>
-            </a:r>
-          </a:p>
-          <a:p>
-            <a:r>
-              <a:t>5. Cheap training plus a short check on detailed physics works.</a:t>
-            </a:r>
-          </a:p>
-          <a:p>
-            <a:r>
-              <a:t>NUMBERS</a:t>
-            </a:r>
-          </a:p>
-          <a:p>
-            <a:r>
-              <a:t>within 6% · LQR fails in 0.7 s · 15× less than PID · 50,000 extra steps gave a 3.8× better score</a:t>
-            </a:r>
-          </a:p>
-          <a:p>
-            <a:r>
-              <a:t>AVOID</a:t>
-            </a:r>
-          </a:p>
-          <a:p>
-            <a:r>
-              <a:t>Point 5's "detailed physics" means the full multibody tank model, not SPH water.</a:t>
+              <a:t>The review asked for the outputs to be easier to understand, so here are our results in plain words. First, the detailed water simulation can be trusted: as we make it finer, it settles on the exact textbook answer. Second, the quick model gets the rhythm of the sloshing right but not the lean of the water when the tank is held tilted. Third, a controller designed only on that quick model fails on real water. Fourth, the learning controller calms real water best, but only for about five seconds. And fifth, training cheaply and then checking briefly on detailed physics is an effective way to work.</a:t>
             </a:r>
           </a:p>
         </p:txBody>
@@ -2863,62 +2433,7 @@
           <a:lstStyle/>
           <a:p>
             <a:r>
-              <a:t>IN ONE SENTENCE</a:t>
-            </a:r>
-          </a:p>
-          <a:p>
-            <a:r>
-              <a:t>Our results show learning control can work on realistic water, warn that simple models can mislead classic controllers, give a cheap and effective way to design such controllers, show when the quick model can be trusted, and give a path to a road-tanker tilting system.</a:t>
-            </a:r>
-          </a:p>
-          <a:p>
-            <a:r>
-              <a:t>SAY IN YOUR OWN WORDS</a:t>
-            </a:r>
-          </a:p>
-          <a:p>
-            <a:r>
-              <a:t>• Learning control works on realistic water, not only on the model it was trained on.</a:t>
-            </a:r>
-          </a:p>
-          <a:p>
-            <a:r>
-              <a:t>• A classic controller can fail when its model is too simple: a warning for anyone designing on equivalent models.</a:t>
-            </a:r>
-          </a:p>
-          <a:p>
-            <a:r>
-              <a:t>• A practical recipe: train cheaply, fine-tune briefly on realistic physics, and stop early.</a:t>
-            </a:r>
-          </a:p>
-          <a:p>
-            <a:r>
-              <a:t>• We now know where the cheap model can be trusted.</a:t>
-            </a:r>
-          </a:p>
-          <a:p>
-            <a:r>
-              <a:t>• For the road tanker: an active tilting cradle could be designed and trained on the cheap model and checked on detailed fluid before anything is built.</a:t>
-            </a:r>
-          </a:p>
-          <a:p>
-            <a:r>
-              <a:t>KEY LINE</a:t>
-            </a:r>
-          </a:p>
-          <a:p>
-            <a:r>
-              <a:t>"Design it cheaply, check it on realistic water, and only then build it."</a:t>
-            </a:r>
-          </a:p>
-          <a:p>
-            <a:r>
-              <a:t>AVOID</a:t>
-            </a:r>
-          </a:p>
-          <a:p>
-            <a:r>
-              <a:t>The tanker cradle is a proposed route, not something we built or proved.</a:t>
+              <a:t>What is the significance of these results? First, learning control works on realistic water, not only on the model it was trained on. Second, a classic model-based controller can fail when its model is too simple, which is a warning for anyone designing on equivalent models. Third, we have a practical recipe: train cheaply, fine-tune briefly on realistic physics, and stop early. Fourth, we now know where the cheap model can be trusted. Fifth, for our main application, a road tanker, this gives a route to an active tilting cradle: design and train it on the cheap model, check it on detailed fluid, and only then build it.</a:t>
             </a:r>
           </a:p>
         </p:txBody>
@@ -2988,67 +2503,7 @@
           <a:lstStyle/>
           <a:p>
             <a:r>
-              <a:t>IN ONE SENTENCE</a:t>
-            </a:r>
-          </a:p>
-          <a:p>
-            <a:r>
-              <a:t>The detailed simulation is accurate for the slow water shift, the fast model is good for rhythm but not for tilt, and on real water the learning controller calms it best but only for about 5 seconds.</a:t>
-            </a:r>
-          </a:p>
-          <a:p>
-            <a:r>
-              <a:t>SAY IN YOUR OWN WORDS</a:t>
-            </a:r>
-          </a:p>
-          <a:p>
-            <a:r>
-              <a:t>• At the start we asked three questions; here are the answers.</a:t>
-            </a:r>
-          </a:p>
-          <a:p>
-            <a:r>
-              <a:t>• 1: the detailed SPH is accurate for the slow response: it converges and lands close to the exact answer.</a:t>
-            </a:r>
-          </a:p>
-          <a:p>
-            <a:r>
-              <a:t>• 2: the fast pendulum gets the sloshing frequency right but misses the water re-levelling, which matters when a controller tilts the tank slowly.</a:t>
-            </a:r>
-          </a:p>
-          <a:p>
-            <a:r>
-              <a:t>• 3: on real water, LQR fails, PID is stable but sloppier, and PPO leaves far less sloshing but for about 5 seconds.</a:t>
-            </a:r>
-          </a:p>
-          <a:p>
-            <a:r>
-              <a:t>NUMBERS</a:t>
-            </a:r>
-          </a:p>
-          <a:p>
-            <a:r>
-              <a:t>3.1% · GCI 6.4% · within 6% · 15× less · about 5 s</a:t>
-            </a:r>
-          </a:p>
-          <a:p>
-            <a:r>
-              <a:t>KEY LINE</a:t>
-            </a:r>
-          </a:p>
-          <a:p>
-            <a:r>
-              <a:t>"Three questions, three answers."</a:t>
-            </a:r>
-          </a:p>
-          <a:p>
-            <a:r>
-              <a:t>AVOID</a:t>
-            </a:r>
-          </a:p>
-          <a:p>
-            <a:r>
-              <a:t>"Accurate" means verified against exact answers, not validated by experiment.</a:t>
+              <a:t>To conclude, here are our three questions, answered. First, the detailed SPH simulation is accurate for the slow response: it converges steadily and comes within 3.1 percent of the exact answer. Second, the fast pendulum model gets the sloshing frequency right, within 6 percent, but misses the water re-levelling, which dominates when a controller tilts the tank slowly. Third, on real water, the LQR designed on that pendulum fails, PID is stable but leaves more sloshing, and the learning controller leaves about 15 times less sloshing but is stable for only about five seconds.</a:t>
             </a:r>
           </a:p>
         </p:txBody>
@@ -3118,52 +2573,7 @@
           <a:lstStyle/>
           <a:p>
             <a:r>
-              <a:t>IN ONE SENTENCE</a:t>
-            </a:r>
-          </a:p>
-          <a:p>
-            <a:r>
-              <a:t>This is a simulation checked against exact formulas, not experiments; it measures overall water motion, not wall pressures; the control tests were coarse and done once each; the learning controller lasts about 5 seconds; and the controllers could see things a real tank can't easily measure.</a:t>
-            </a:r>
-          </a:p>
-          <a:p>
-            <a:r>
-              <a:t>SAY IN YOUR OWN WORDS (say it confidently, not apologetically)</a:t>
-            </a:r>
-          </a:p>
-          <a:p>
-            <a:r>
-              <a:t>• This is a simulation study, verified against exact answers but not yet validated by experiment.</a:t>
-            </a:r>
-          </a:p>
-          <a:p>
-            <a:r>
-              <a:t>• We measured bulk quantities (centre of mass, energy), not wall pressures.</a:t>
-            </a:r>
-          </a:p>
-          <a:p>
-            <a:r>
-              <a:t>• Damping at 10 mm is mostly numerical; real viscosity, surface tension and air are not modelled.</a:t>
-            </a:r>
-          </a:p>
-          <a:p>
-            <a:r>
-              <a:t>• The two-way control runs used the coarse 10 mm size, with one run per controller.</a:t>
-            </a:r>
-          </a:p>
-          <a:p>
-            <a:r>
-              <a:t>• The learning controller is stable for about 5 s, and it reads the water's position directly, which a real tank can't easily measure.</a:t>
-            </a:r>
-          </a:p>
-          <a:p>
-            <a:r>
-              <a:t>KEY LINE</a:t>
-            </a:r>
-          </a:p>
-          <a:p>
-            <a:r>
-              <a:t>"Each of these is addressed in our future scope."</a:t>
+              <a:t>We also state our limitations openly. This is a simulation study, verified against exact answers but not yet validated by experiment. We extracted bulk quantities, not wall pressures. The damping at 10 millimetres is mostly numerical, and real viscosity, surface tension and air are not modelled. On the control side, the two-way runs were done only at the coarse 10 millimetre size, with one run per controller, the learning controller is stable for only about five seconds, and the controllers read the water's position directly, which a real tank cannot easily measure.</a:t>
             </a:r>
           </a:p>
         </p:txBody>
@@ -3233,52 +2643,7 @@
           <a:lstStyle/>
           <a:p>
             <a:r>
-              <a:t>IN ONE SENTENCE</a:t>
-            </a:r>
-          </a:p>
-          <a:p>
-            <a:r>
-              <a:t>Next we would build a real tank to test against, run finer simulations, improve the simple model, test the controllers more thoroughly, and make the controller work with real sensors.</a:t>
-            </a:r>
-          </a:p>
-          <a:p>
-            <a:r>
-              <a:t>SAY IN YOUR OWN WORDS</a:t>
-            </a:r>
-          </a:p>
-          <a:p>
-            <a:r>
-              <a:t>• First priority: a physical acrylic rig of the same size, measuring wall pressure and surface height, then scaling up towards a tanker compartment.</a:t>
-            </a:r>
-          </a:p>
-          <a:p>
-            <a:r>
-              <a:t>• Repeat free sloshing at 5, 3 and 2 mm to separate real damping from numerical damping.</a:t>
-            </a:r>
-          </a:p>
-          <a:p>
-            <a:r>
-              <a:t>• Add the missing hydrostatic tilt term to the pendulum and redesign LQR on it.</a:t>
-            </a:r>
-          </a:p>
-          <a:p>
-            <a:r>
-              <a:t>• Stronger control tests: finer particles, several runs per controller, better walls.</a:t>
-            </a:r>
-          </a:p>
-          <a:p>
-            <a:r>
-              <a:t>• Hardware-ready control: use wall-pressure sensors instead of the water's exact position (a first version was tried).</a:t>
-            </a:r>
-          </a:p>
-          <a:p>
-            <a:r>
-              <a:t>KEY LINE</a:t>
-            </a:r>
-          </a:p>
-          <a:p>
-            <a:r>
-              <a:t>"Each limitation has a matching next step."</a:t>
+              <a:t>For future work, the first priority is a physical rig of the same size, to validate the simulation with measured wall pressures and surface heights, and then a larger test towards a real tanker compartment. Second, repeat the free-sloshing test at finer particle sizes to separate real from numerical damping. Third, give the simple pendulum model the missing hydrostatic tilt term and redesign the LQR on it. Fourth, repeat the control tests at a finer resolution with more runs. And finally, move towards hardware by using wall-pressure sensors instead of the water's position.</a:t>
             </a:r>
           </a:p>
         </p:txBody>
@@ -3348,17 +2713,7 @@
           <a:lstStyle/>
           <a:p>
             <a:r>
-              <a:t>SAY</a:t>
-            </a:r>
-          </a:p>
-          <a:p>
-            <a:r>
-              <a:t>• These are the key references; the full list of 35 is in our report.</a:t>
-            </a:r>
-          </a:p>
-          <a:p>
-            <a:r>
-              <a:t>• Then move to the last slide; this takes about 10 seconds.</a:t>
+              <a:t>These are the key references; the full list of 35 is in our report.</a:t>
             </a:r>
           </a:p>
         </p:txBody>
@@ -3428,17 +2783,7 @@
           <a:lstStyle/>
           <a:p>
             <a:r>
-              <a:t>SAY</a:t>
-            </a:r>
-          </a:p>
-          <a:p>
-            <a:r>
-              <a:t>• Thank you for your attention. We would be happy to answer any questions.</a:t>
-            </a:r>
-          </a:p>
-          <a:p>
-            <a:r>
-              <a:t>• Keep this slide up during questions: it has the GitHub link to the full project.</a:t>
+              <a:t>Thank you for your attention. We would be happy to answer any questions.</a:t>
             </a:r>
           </a:p>
         </p:txBody>

</xml_diff>

<commit_message>
Keep the project link only on the closing slide
</commit_message>
<xml_diff>
--- a/docs/presentation/Liquid_Sloshing_Final_Presentation.pptx
+++ b/docs/presentation/Liquid_Sloshing_Final_Presentation.pptx
@@ -2153,7 +2153,7 @@
           <a:lstStyle/>
           <a:p>
             <a:r>
-              <a:t>Everything we have shown can also be explored interactively in a web browser. The 3D Sloshing Lab replays the real SPH water inside the tilting tank, lets you drive the tank yourself, shows the tank on a truck bed over a bumpy road, and compares the four particle sizes. The interactive report has a live demo where you set the motor torque, kick the water and try to calm it yourself, along with all our results. Both open directly from our presentation folder in any web browser, and need no internet connection. The complete project, with all the code, trained models, results and the paper, is on GitHub at the link at the bottom of the slide.</a:t>
+              <a:t>Everything we have shown can also be explored interactively in a web browser. The 3D Sloshing Lab replays the real SPH water inside the tilting tank, lets you drive the tank yourself, shows the tank on a truck bed over a bumpy road, and compares the four particle sizes. The interactive report has a live demo where you set the motor torque, kick the water and try to calm it yourself, along with all our results. Both open directly from our presentation folder in any web browser, and need no internet connection.</a:t>
             </a:r>
           </a:p>
         </p:txBody>
@@ -27789,7 +27789,7 @@
         <p:spPr>
           <a:xfrm>
             <a:off x="548640" y="2468880"/>
-            <a:ext cx="5440680" cy="2514600"/>
+            <a:ext cx="5440680" cy="2880360"/>
           </a:xfrm>
           <a:prstGeom prst="roundRect">
             <a:avLst>
@@ -27899,7 +27899,7 @@
         </p:nvSpPr>
         <p:spPr>
           <a:xfrm>
-            <a:off x="548640" y="5074920"/>
+            <a:off x="548640" y="5440680"/>
             <a:ext cx="5440680" cy="457200"/>
           </a:xfrm>
           <a:prstGeom prst="rect">
@@ -27934,7 +27934,7 @@
         </p:nvSpPr>
         <p:spPr>
           <a:xfrm>
-            <a:off x="548640" y="5486400"/>
+            <a:off x="548640" y="5870448"/>
             <a:ext cx="5440680" cy="365760"/>
           </a:xfrm>
           <a:prstGeom prst="rect">
@@ -28033,7 +28033,7 @@
         <p:spPr>
           <a:xfrm>
             <a:off x="6172200" y="2468880"/>
-            <a:ext cx="5440680" cy="2514600"/>
+            <a:ext cx="5440680" cy="2880360"/>
           </a:xfrm>
           <a:prstGeom prst="roundRect">
             <a:avLst>
@@ -28143,7 +28143,7 @@
         </p:nvSpPr>
         <p:spPr>
           <a:xfrm>
-            <a:off x="6172200" y="5074920"/>
+            <a:off x="6172200" y="5440680"/>
             <a:ext cx="5440680" cy="457200"/>
           </a:xfrm>
           <a:prstGeom prst="rect">
@@ -28178,7 +28178,7 @@
         </p:nvSpPr>
         <p:spPr>
           <a:xfrm>
-            <a:off x="6172200" y="5486400"/>
+            <a:off x="6172200" y="5870448"/>
             <a:ext cx="5440680" cy="365760"/>
           </a:xfrm>
           <a:prstGeom prst="rect">
@@ -28212,51 +28212,6 @@
       <p:sp>
         <p:nvSpPr>
           <p:cNvPr id="12" name="TextBox 11"/>
-          <p:cNvSpPr txBox="1"/>
-          <p:nvPr/>
-        </p:nvSpPr>
-        <p:spPr>
-          <a:xfrm>
-            <a:off x="548640" y="5897880"/>
-            <a:ext cx="11064240" cy="411480"/>
-          </a:xfrm>
-          <a:prstGeom prst="rect">
-            <a:avLst/>
-          </a:prstGeom>
-          <a:noFill/>
-        </p:spPr>
-        <p:txBody>
-          <a:bodyPr wrap="square">
-            <a:spAutoFit/>
-          </a:bodyPr>
-          <a:lstStyle/>
-          <a:p>
-            <a:pPr algn="ctr"/>
-            <a:r>
-              <a:rPr sz="1400">
-                <a:solidFill>
-                  <a:srgbClr val="2B2B2B"/>
-                </a:solidFill>
-                <a:latin typeface="Calibri"/>
-              </a:rPr>
-              <a:t>Full project (code, models, results, paper): </a:t>
-            </a:r>
-            <a:r>
-              <a:rPr sz="1400" b="1">
-                <a:solidFill>
-                  <a:srgbClr val="1F5F86"/>
-                </a:solidFill>
-                <a:latin typeface="Calibri"/>
-                <a:hlinkClick r:id="rId4"/>
-              </a:rPr>
-              <a:t>https://github.com/RacerRed505/LiquidSloshingRL-Capstone</a:t>
-            </a:r>
-          </a:p>
-        </p:txBody>
-      </p:sp>
-      <p:sp>
-        <p:nvSpPr>
-          <p:cNvPr id="13" name="TextBox 12"/>
           <p:cNvSpPr txBox="1"/>
           <p:nvPr/>
         </p:nvSpPr>
@@ -28295,7 +28250,7 @@
       </p:sp>
       <p:sp>
         <p:nvSpPr>
-          <p:cNvPr id="14" name="TextBox 13"/>
+          <p:cNvPr id="13" name="TextBox 12"/>
           <p:cNvSpPr txBox="1"/>
           <p:nvPr/>
         </p:nvSpPr>

</xml_diff>

<commit_message>
Add a project timeline to the presentation
</commit_message>
<xml_diff>
--- a/docs/presentation/Liquid_Sloshing_Final_Presentation.pptx
+++ b/docs/presentation/Liquid_Sloshing_Final_Presentation.pptx
@@ -683,7 +683,7 @@
           <a:lstStyle/>
           <a:p>
             <a:r>
-              <a:t>Our methodology has six steps, grouped into design, analysis and validation. We first defined the problem and the tank design. We then built the model: the tank, pivot and motor, the simple pendulum model of the water, and a training environment for the controllers. Next we trained and tuned three controllers on the fast model. We then simulated the real water with SPH on a graphics card at four particle sizes, verified the SPH results against exact answers, and finally compared the controllers in the fully coupled tank. All steps read the same configuration file, so the models can never disagree on a dimension or a mass.</a:t>
+              <a:t>Our methodology has six steps, grouped into design, analysis and validation. We first defined the problem and the tank design. We then built the model: the tank, pivot and motor, the simple pendulum model of the water, and a training environment for the controllers. Next we trained and tuned three controllers on the fast model. We then simulated the real water with SPH on a graphics card at four particle sizes, verified the SPH results against exact answers, and finally compared the controllers in the fully coupled tank. All steps read the same configuration file, so the models can never disagree on a dimension or a mass. The work ran from June to October 2026: design and modelling in June and July, the controllers in July and August, the SPH simulations and checks in August and September, and the two-way comparison, the second-review checks, the paper, the report and this presentation in September and October. A large share of that time went into GPU runs, the longest of which took about nine hours each.</a:t>
             </a:r>
           </a:p>
         </p:txBody>
@@ -11562,9 +11562,68 @@
           </a:p>
         </p:txBody>
       </p:sp>
+      <p:sp>
+        <p:nvSpPr>
+          <p:cNvPr id="6" name="Rounded Rectangle 5"/>
+          <p:cNvSpPr/>
+          <p:nvPr/>
+        </p:nvSpPr>
+        <p:spPr>
+          <a:xfrm>
+            <a:off x="731520" y="4279392"/>
+            <a:ext cx="1287780" cy="292608"/>
+          </a:xfrm>
+          <a:prstGeom prst="roundRect">
+            <a:avLst>
+              <a:gd name="adj" fmla="val 50000"/>
+            </a:avLst>
+          </a:prstGeom>
+          <a:solidFill>
+            <a:srgbClr val="FFFFFF"/>
+          </a:solidFill>
+          <a:ln>
+            <a:noFill/>
+          </a:ln>
+          <a:effectLst/>
+        </p:spPr>
+        <p:style>
+          <a:lnRef idx="1">
+            <a:schemeClr val="accent1"/>
+          </a:lnRef>
+          <a:fillRef idx="3">
+            <a:schemeClr val="accent1"/>
+          </a:fillRef>
+          <a:effectRef idx="2">
+            <a:schemeClr val="accent1"/>
+          </a:effectRef>
+          <a:fontRef idx="minor">
+            <a:schemeClr val="lt1"/>
+          </a:fontRef>
+        </p:style>
+        <p:txBody>
+          <a:bodyPr rtlCol="0" anchor="ctr" lIns="36576" rIns="36576" tIns="36576" bIns="36576" wrap="square"/>
+          <a:lstStyle/>
+          <a:p>
+            <a:pPr algn="ctr">
+              <a:spcAft>
+                <a:spcPts val="400"/>
+              </a:spcAft>
+            </a:pPr>
+            <a:r>
+              <a:rPr sz="1200" b="1" i="0">
+                <a:solidFill>
+                  <a:srgbClr val="BC312C"/>
+                </a:solidFill>
+                <a:latin typeface="Calibri"/>
+              </a:rPr>
+              <a:t>Jun 2026</a:t>
+            </a:r>
+          </a:p>
+        </p:txBody>
+      </p:sp>
       <p:cxnSp>
         <p:nvCxnSpPr>
-          <p:cNvPr id="6" name="Connector 5"/>
+          <p:cNvPr id="7" name="Connector 6"/>
           <p:cNvCxnSpPr/>
           <p:nvPr/>
         </p:nvCxnSpPr>
@@ -11600,7 +11659,7 @@
       </p:cxnSp>
       <p:sp>
         <p:nvSpPr>
-          <p:cNvPr id="7" name="Oval 6"/>
+          <p:cNvPr id="8" name="Oval 7"/>
           <p:cNvSpPr/>
           <p:nvPr/>
         </p:nvSpPr>
@@ -11657,7 +11716,7 @@
       </p:sp>
       <p:sp>
         <p:nvSpPr>
-          <p:cNvPr id="8" name="Rounded Rectangle 7"/>
+          <p:cNvPr id="9" name="Rounded Rectangle 8"/>
           <p:cNvSpPr/>
           <p:nvPr/>
         </p:nvSpPr>
@@ -11730,9 +11789,68 @@
           </a:p>
         </p:txBody>
       </p:sp>
+      <p:sp>
+        <p:nvSpPr>
+          <p:cNvPr id="10" name="Rounded Rectangle 9"/>
+          <p:cNvSpPr/>
+          <p:nvPr/>
+        </p:nvSpPr>
+        <p:spPr>
+          <a:xfrm>
+            <a:off x="2613660" y="4279392"/>
+            <a:ext cx="1287780" cy="292608"/>
+          </a:xfrm>
+          <a:prstGeom prst="roundRect">
+            <a:avLst>
+              <a:gd name="adj" fmla="val 50000"/>
+            </a:avLst>
+          </a:prstGeom>
+          <a:solidFill>
+            <a:srgbClr val="FFFFFF"/>
+          </a:solidFill>
+          <a:ln>
+            <a:noFill/>
+          </a:ln>
+          <a:effectLst/>
+        </p:spPr>
+        <p:style>
+          <a:lnRef idx="1">
+            <a:schemeClr val="accent1"/>
+          </a:lnRef>
+          <a:fillRef idx="3">
+            <a:schemeClr val="accent1"/>
+          </a:fillRef>
+          <a:effectRef idx="2">
+            <a:schemeClr val="accent1"/>
+          </a:effectRef>
+          <a:fontRef idx="minor">
+            <a:schemeClr val="lt1"/>
+          </a:fontRef>
+        </p:style>
+        <p:txBody>
+          <a:bodyPr rtlCol="0" anchor="ctr" lIns="36576" rIns="36576" tIns="36576" bIns="36576" wrap="square"/>
+          <a:lstStyle/>
+          <a:p>
+            <a:pPr algn="ctr">
+              <a:spcAft>
+                <a:spcPts val="400"/>
+              </a:spcAft>
+            </a:pPr>
+            <a:r>
+              <a:rPr sz="1200" b="1" i="0">
+                <a:solidFill>
+                  <a:srgbClr val="BC312C"/>
+                </a:solidFill>
+                <a:latin typeface="Calibri"/>
+              </a:rPr>
+              <a:t>Jul 2026</a:t>
+            </a:r>
+          </a:p>
+        </p:txBody>
+      </p:sp>
       <p:cxnSp>
         <p:nvCxnSpPr>
-          <p:cNvPr id="9" name="Connector 8"/>
+          <p:cNvPr id="11" name="Connector 10"/>
           <p:cNvCxnSpPr/>
           <p:nvPr/>
         </p:nvCxnSpPr>
@@ -11768,7 +11886,7 @@
       </p:cxnSp>
       <p:sp>
         <p:nvSpPr>
-          <p:cNvPr id="10" name="Oval 9"/>
+          <p:cNvPr id="12" name="Oval 11"/>
           <p:cNvSpPr/>
           <p:nvPr/>
         </p:nvSpPr>
@@ -11825,7 +11943,7 @@
       </p:sp>
       <p:sp>
         <p:nvSpPr>
-          <p:cNvPr id="11" name="Rounded Rectangle 10"/>
+          <p:cNvPr id="13" name="Rounded Rectangle 12"/>
           <p:cNvSpPr/>
           <p:nvPr/>
         </p:nvSpPr>
@@ -11898,9 +12016,68 @@
           </a:p>
         </p:txBody>
       </p:sp>
+      <p:sp>
+        <p:nvSpPr>
+          <p:cNvPr id="14" name="Rounded Rectangle 13"/>
+          <p:cNvSpPr/>
+          <p:nvPr/>
+        </p:nvSpPr>
+        <p:spPr>
+          <a:xfrm>
+            <a:off x="4495800" y="4279392"/>
+            <a:ext cx="1287780" cy="292608"/>
+          </a:xfrm>
+          <a:prstGeom prst="roundRect">
+            <a:avLst>
+              <a:gd name="adj" fmla="val 50000"/>
+            </a:avLst>
+          </a:prstGeom>
+          <a:solidFill>
+            <a:srgbClr val="FFFFFF"/>
+          </a:solidFill>
+          <a:ln>
+            <a:noFill/>
+          </a:ln>
+          <a:effectLst/>
+        </p:spPr>
+        <p:style>
+          <a:lnRef idx="1">
+            <a:schemeClr val="accent1"/>
+          </a:lnRef>
+          <a:fillRef idx="3">
+            <a:schemeClr val="accent1"/>
+          </a:fillRef>
+          <a:effectRef idx="2">
+            <a:schemeClr val="accent1"/>
+          </a:effectRef>
+          <a:fontRef idx="minor">
+            <a:schemeClr val="lt1"/>
+          </a:fontRef>
+        </p:style>
+        <p:txBody>
+          <a:bodyPr rtlCol="0" anchor="ctr" lIns="36576" rIns="36576" tIns="36576" bIns="36576" wrap="square"/>
+          <a:lstStyle/>
+          <a:p>
+            <a:pPr algn="ctr">
+              <a:spcAft>
+                <a:spcPts val="400"/>
+              </a:spcAft>
+            </a:pPr>
+            <a:r>
+              <a:rPr sz="1200" b="1" i="0">
+                <a:solidFill>
+                  <a:srgbClr val="BC312C"/>
+                </a:solidFill>
+                <a:latin typeface="Calibri"/>
+              </a:rPr>
+              <a:t>Jul – Aug</a:t>
+            </a:r>
+          </a:p>
+        </p:txBody>
+      </p:sp>
       <p:cxnSp>
         <p:nvCxnSpPr>
-          <p:cNvPr id="12" name="Connector 11"/>
+          <p:cNvPr id="15" name="Connector 14"/>
           <p:cNvCxnSpPr/>
           <p:nvPr/>
         </p:nvCxnSpPr>
@@ -11936,7 +12113,7 @@
       </p:cxnSp>
       <p:sp>
         <p:nvSpPr>
-          <p:cNvPr id="13" name="Oval 12"/>
+          <p:cNvPr id="16" name="Oval 15"/>
           <p:cNvSpPr/>
           <p:nvPr/>
         </p:nvSpPr>
@@ -11993,7 +12170,7 @@
       </p:sp>
       <p:sp>
         <p:nvSpPr>
-          <p:cNvPr id="14" name="Rounded Rectangle 13"/>
+          <p:cNvPr id="17" name="Rounded Rectangle 16"/>
           <p:cNvSpPr/>
           <p:nvPr/>
         </p:nvSpPr>
@@ -12066,9 +12243,68 @@
           </a:p>
         </p:txBody>
       </p:sp>
+      <p:sp>
+        <p:nvSpPr>
+          <p:cNvPr id="18" name="Rounded Rectangle 17"/>
+          <p:cNvSpPr/>
+          <p:nvPr/>
+        </p:nvSpPr>
+        <p:spPr>
+          <a:xfrm>
+            <a:off x="6377940" y="4279392"/>
+            <a:ext cx="1287780" cy="292608"/>
+          </a:xfrm>
+          <a:prstGeom prst="roundRect">
+            <a:avLst>
+              <a:gd name="adj" fmla="val 50000"/>
+            </a:avLst>
+          </a:prstGeom>
+          <a:solidFill>
+            <a:srgbClr val="FFFFFF"/>
+          </a:solidFill>
+          <a:ln>
+            <a:noFill/>
+          </a:ln>
+          <a:effectLst/>
+        </p:spPr>
+        <p:style>
+          <a:lnRef idx="1">
+            <a:schemeClr val="accent1"/>
+          </a:lnRef>
+          <a:fillRef idx="3">
+            <a:schemeClr val="accent1"/>
+          </a:fillRef>
+          <a:effectRef idx="2">
+            <a:schemeClr val="accent1"/>
+          </a:effectRef>
+          <a:fontRef idx="minor">
+            <a:schemeClr val="lt1"/>
+          </a:fontRef>
+        </p:style>
+        <p:txBody>
+          <a:bodyPr rtlCol="0" anchor="ctr" lIns="36576" rIns="36576" tIns="36576" bIns="36576" wrap="square"/>
+          <a:lstStyle/>
+          <a:p>
+            <a:pPr algn="ctr">
+              <a:spcAft>
+                <a:spcPts val="400"/>
+              </a:spcAft>
+            </a:pPr>
+            <a:r>
+              <a:rPr sz="1200" b="1" i="0">
+                <a:solidFill>
+                  <a:srgbClr val="BC312C"/>
+                </a:solidFill>
+                <a:latin typeface="Calibri"/>
+              </a:rPr>
+              <a:t>Aug – Sep</a:t>
+            </a:r>
+          </a:p>
+        </p:txBody>
+      </p:sp>
       <p:cxnSp>
         <p:nvCxnSpPr>
-          <p:cNvPr id="15" name="Connector 14"/>
+          <p:cNvPr id="19" name="Connector 18"/>
           <p:cNvCxnSpPr/>
           <p:nvPr/>
         </p:nvCxnSpPr>
@@ -12104,7 +12340,7 @@
       </p:cxnSp>
       <p:sp>
         <p:nvSpPr>
-          <p:cNvPr id="16" name="Oval 15"/>
+          <p:cNvPr id="20" name="Oval 19"/>
           <p:cNvSpPr/>
           <p:nvPr/>
         </p:nvSpPr>
@@ -12161,7 +12397,7 @@
       </p:sp>
       <p:sp>
         <p:nvSpPr>
-          <p:cNvPr id="17" name="Rounded Rectangle 16"/>
+          <p:cNvPr id="21" name="Rounded Rectangle 20"/>
           <p:cNvSpPr/>
           <p:nvPr/>
         </p:nvSpPr>
@@ -12234,9 +12470,68 @@
           </a:p>
         </p:txBody>
       </p:sp>
+      <p:sp>
+        <p:nvSpPr>
+          <p:cNvPr id="22" name="Rounded Rectangle 21"/>
+          <p:cNvSpPr/>
+          <p:nvPr/>
+        </p:nvSpPr>
+        <p:spPr>
+          <a:xfrm>
+            <a:off x="8260080" y="4279392"/>
+            <a:ext cx="1287780" cy="292608"/>
+          </a:xfrm>
+          <a:prstGeom prst="roundRect">
+            <a:avLst>
+              <a:gd name="adj" fmla="val 50000"/>
+            </a:avLst>
+          </a:prstGeom>
+          <a:solidFill>
+            <a:srgbClr val="FFFFFF"/>
+          </a:solidFill>
+          <a:ln>
+            <a:noFill/>
+          </a:ln>
+          <a:effectLst/>
+        </p:spPr>
+        <p:style>
+          <a:lnRef idx="1">
+            <a:schemeClr val="accent1"/>
+          </a:lnRef>
+          <a:fillRef idx="3">
+            <a:schemeClr val="accent1"/>
+          </a:fillRef>
+          <a:effectRef idx="2">
+            <a:schemeClr val="accent1"/>
+          </a:effectRef>
+          <a:fontRef idx="minor">
+            <a:schemeClr val="lt1"/>
+          </a:fontRef>
+        </p:style>
+        <p:txBody>
+          <a:bodyPr rtlCol="0" anchor="ctr" lIns="36576" rIns="36576" tIns="36576" bIns="36576" wrap="square"/>
+          <a:lstStyle/>
+          <a:p>
+            <a:pPr algn="ctr">
+              <a:spcAft>
+                <a:spcPts val="400"/>
+              </a:spcAft>
+            </a:pPr>
+            <a:r>
+              <a:rPr sz="1200" b="1" i="0">
+                <a:solidFill>
+                  <a:srgbClr val="BC312C"/>
+                </a:solidFill>
+                <a:latin typeface="Calibri"/>
+              </a:rPr>
+              <a:t>Sep</a:t>
+            </a:r>
+          </a:p>
+        </p:txBody>
+      </p:sp>
       <p:cxnSp>
         <p:nvCxnSpPr>
-          <p:cNvPr id="18" name="Connector 17"/>
+          <p:cNvPr id="23" name="Connector 22"/>
           <p:cNvCxnSpPr/>
           <p:nvPr/>
         </p:nvCxnSpPr>
@@ -12272,7 +12567,7 @@
       </p:cxnSp>
       <p:sp>
         <p:nvSpPr>
-          <p:cNvPr id="19" name="Oval 18"/>
+          <p:cNvPr id="24" name="Oval 23"/>
           <p:cNvSpPr/>
           <p:nvPr/>
         </p:nvSpPr>
@@ -12329,7 +12624,7 @@
       </p:sp>
       <p:sp>
         <p:nvSpPr>
-          <p:cNvPr id="20" name="Rounded Rectangle 19"/>
+          <p:cNvPr id="25" name="Rounded Rectangle 24"/>
           <p:cNvSpPr/>
           <p:nvPr/>
         </p:nvSpPr>
@@ -12404,7 +12699,66 @@
       </p:sp>
       <p:sp>
         <p:nvSpPr>
-          <p:cNvPr id="21" name="Rounded Rectangle 20"/>
+          <p:cNvPr id="26" name="Rounded Rectangle 25"/>
+          <p:cNvSpPr/>
+          <p:nvPr/>
+        </p:nvSpPr>
+        <p:spPr>
+          <a:xfrm>
+            <a:off x="10142220" y="4279392"/>
+            <a:ext cx="1287780" cy="292608"/>
+          </a:xfrm>
+          <a:prstGeom prst="roundRect">
+            <a:avLst>
+              <a:gd name="adj" fmla="val 50000"/>
+            </a:avLst>
+          </a:prstGeom>
+          <a:solidFill>
+            <a:srgbClr val="FFFFFF"/>
+          </a:solidFill>
+          <a:ln>
+            <a:noFill/>
+          </a:ln>
+          <a:effectLst/>
+        </p:spPr>
+        <p:style>
+          <a:lnRef idx="1">
+            <a:schemeClr val="accent1"/>
+          </a:lnRef>
+          <a:fillRef idx="3">
+            <a:schemeClr val="accent1"/>
+          </a:fillRef>
+          <a:effectRef idx="2">
+            <a:schemeClr val="accent1"/>
+          </a:effectRef>
+          <a:fontRef idx="minor">
+            <a:schemeClr val="lt1"/>
+          </a:fontRef>
+        </p:style>
+        <p:txBody>
+          <a:bodyPr rtlCol="0" anchor="ctr" lIns="36576" rIns="36576" tIns="36576" bIns="36576" wrap="square"/>
+          <a:lstStyle/>
+          <a:p>
+            <a:pPr algn="ctr">
+              <a:spcAft>
+                <a:spcPts val="400"/>
+              </a:spcAft>
+            </a:pPr>
+            <a:r>
+              <a:rPr sz="1200" b="1" i="0">
+                <a:solidFill>
+                  <a:srgbClr val="BC312C"/>
+                </a:solidFill>
+                <a:latin typeface="Calibri"/>
+              </a:rPr>
+              <a:t>Sep – Oct</a:t>
+            </a:r>
+          </a:p>
+        </p:txBody>
+      </p:sp>
+      <p:sp>
+        <p:nvSpPr>
+          <p:cNvPr id="27" name="Rounded Rectangle 26"/>
           <p:cNvSpPr/>
           <p:nvPr/>
         </p:nvSpPr>
@@ -12463,7 +12817,7 @@
       </p:sp>
       <p:sp>
         <p:nvSpPr>
-          <p:cNvPr id="22" name="Rounded Rectangle 21"/>
+          <p:cNvPr id="28" name="Rounded Rectangle 27"/>
           <p:cNvSpPr/>
           <p:nvPr/>
         </p:nvSpPr>
@@ -12522,7 +12876,7 @@
       </p:sp>
       <p:sp>
         <p:nvSpPr>
-          <p:cNvPr id="23" name="Rounded Rectangle 22"/>
+          <p:cNvPr id="29" name="Rounded Rectangle 28"/>
           <p:cNvSpPr/>
           <p:nvPr/>
         </p:nvSpPr>
@@ -12581,7 +12935,55 @@
       </p:sp>
       <p:sp>
         <p:nvSpPr>
-          <p:cNvPr id="24" name="TextBox 23"/>
+          <p:cNvPr id="30" name="TextBox 29"/>
+          <p:cNvSpPr txBox="1"/>
+          <p:nvPr/>
+        </p:nvSpPr>
+        <p:spPr>
+          <a:xfrm>
+            <a:off x="548640" y="5532120"/>
+            <a:ext cx="11064240" cy="411480"/>
+          </a:xfrm>
+          <a:prstGeom prst="rect">
+            <a:avLst/>
+          </a:prstGeom>
+          <a:noFill/>
+        </p:spPr>
+        <p:txBody>
+          <a:bodyPr wrap="square" anchor="t" lIns="45720" rIns="45720">
+            <a:spAutoFit/>
+          </a:bodyPr>
+          <a:lstStyle/>
+          <a:p>
+            <a:pPr>
+              <a:spcAft>
+                <a:spcPts val="600"/>
+              </a:spcAft>
+            </a:pPr>
+            <a:r>
+              <a:rPr sz="1300" b="1" i="0">
+                <a:solidFill>
+                  <a:srgbClr val="2B2B2B"/>
+                </a:solidFill>
+                <a:latin typeface="Calibri"/>
+              </a:rPr>
+              <a:t>Timeline: </a:t>
+            </a:r>
+            <a:r>
+              <a:rPr sz="1300" b="0" i="0">
+                <a:solidFill>
+                  <a:srgbClr val="2B2B2B"/>
+                </a:solidFill>
+                <a:latin typeface="Calibri"/>
+              </a:rPr>
+              <a:t>June to October 2026, about five months. October: second-review checks, research paper, report and presentation. The finest SPH runs took up to 9 hours each on the GPU.</a:t>
+            </a:r>
+          </a:p>
+        </p:txBody>
+      </p:sp>
+      <p:sp>
+        <p:nvSpPr>
+          <p:cNvPr id="31" name="TextBox 30"/>
           <p:cNvSpPr txBox="1"/>
           <p:nvPr/>
         </p:nvSpPr>
@@ -12620,7 +13022,7 @@
       </p:sp>
       <p:sp>
         <p:nvSpPr>
-          <p:cNvPr id="25" name="TextBox 24"/>
+          <p:cNvPr id="32" name="TextBox 31"/>
           <p:cNvSpPr txBox="1"/>
           <p:nvPr/>
         </p:nvSpPr>
@@ -28432,7 +28834,7 @@
         </p:nvGraphicFramePr>
         <p:xfrm>
           <a:off x="548640" y="2103120"/>
-          <a:ext cx="11064239" cy="3950208"/>
+          <a:ext cx="11064240" cy="3950208"/>
         </p:xfrm>
         <a:graphic>
           <a:graphicData uri="http://schemas.openxmlformats.org/drawingml/2006/table">
@@ -28441,9 +28843,10 @@
                 <a:tableStyleId>{5940675A-B579-460E-94D1-54222C63F5DA}</a:tableStyleId>
               </a:tblPr>
               <a:tblGrid>
-                <a:gridCol w="3108960"/>
-                <a:gridCol w="4206240"/>
-                <a:gridCol w="3749039"/>
+                <a:gridCol w="2834640"/>
+                <a:gridCol w="3840480"/>
+                <a:gridCol w="3383280"/>
+                <a:gridCol w="1005840"/>
               </a:tblGrid>
               <a:tr h="658368">
                 <a:tc>
@@ -28543,6 +28946,48 @@
                           <a:latin typeface="Calibri"/>
                         </a:rPr>
                         <a:t>Solution</a:t>
+                      </a:r>
+                    </a:p>
+                  </a:txBody>
+                  <a:tcPr marL="73152" marR="73152" marT="36576" marB="36576" anchor="ctr">
+                    <a:lnL w="9525">
+                      <a:solidFill>
+                        <a:srgbClr val="D0D0D0"/>
+                      </a:solidFill>
+                    </a:lnL>
+                    <a:lnR w="9525">
+                      <a:solidFill>
+                        <a:srgbClr val="D0D0D0"/>
+                      </a:solidFill>
+                    </a:lnR>
+                    <a:lnT w="9525">
+                      <a:solidFill>
+                        <a:srgbClr val="D0D0D0"/>
+                      </a:solidFill>
+                    </a:lnT>
+                    <a:lnB w="9525">
+                      <a:solidFill>
+                        <a:srgbClr val="D0D0D0"/>
+                      </a:solidFill>
+                    </a:lnB>
+                    <a:solidFill>
+                      <a:srgbClr val="2B2B2B"/>
+                    </a:solidFill>
+                  </a:tcPr>
+                </a:tc>
+                <a:tc>
+                  <a:txBody>
+                    <a:bodyPr wrap="square"/>
+                    <a:lstStyle/>
+                    <a:p>
+                      <a:r>
+                        <a:rPr sz="1300" b="1">
+                          <a:solidFill>
+                            <a:srgbClr val="FFFFFF"/>
+                          </a:solidFill>
+                          <a:latin typeface="Calibri"/>
+                        </a:rPr>
+                        <a:t>When</a:t>
                       </a:r>
                     </a:p>
                   </a:txBody>
@@ -28700,6 +29145,48 @@
                     </a:solidFill>
                   </a:tcPr>
                 </a:tc>
+                <a:tc>
+                  <a:txBody>
+                    <a:bodyPr wrap="square"/>
+                    <a:lstStyle/>
+                    <a:p>
+                      <a:r>
+                        <a:rPr sz="1300" b="0">
+                          <a:solidFill>
+                            <a:srgbClr val="2B2B2B"/>
+                          </a:solidFill>
+                          <a:latin typeface="Calibri"/>
+                        </a:rPr>
+                        <a:t>Aug – Sep</a:t>
+                      </a:r>
+                    </a:p>
+                  </a:txBody>
+                  <a:tcPr marL="73152" marR="73152" marT="36576" marB="36576" anchor="ctr">
+                    <a:lnL w="9525">
+                      <a:solidFill>
+                        <a:srgbClr val="D0D0D0"/>
+                      </a:solidFill>
+                    </a:lnL>
+                    <a:lnR w="9525">
+                      <a:solidFill>
+                        <a:srgbClr val="D0D0D0"/>
+                      </a:solidFill>
+                    </a:lnR>
+                    <a:lnT w="9525">
+                      <a:solidFill>
+                        <a:srgbClr val="D0D0D0"/>
+                      </a:solidFill>
+                    </a:lnT>
+                    <a:lnB w="9525">
+                      <a:solidFill>
+                        <a:srgbClr val="D0D0D0"/>
+                      </a:solidFill>
+                    </a:lnB>
+                    <a:solidFill>
+                      <a:srgbClr val="FFFFFF"/>
+                    </a:solidFill>
+                  </a:tcPr>
+                </a:tc>
               </a:tr>
               <a:tr h="658368">
                 <a:tc>
@@ -28799,6 +29286,48 @@
                           <a:latin typeface="Calibri"/>
                         </a:rPr>
                         <a:t>Split each 20 ms step into many small steps</a:t>
+                      </a:r>
+                    </a:p>
+                  </a:txBody>
+                  <a:tcPr marL="73152" marR="73152" marT="36576" marB="36576" anchor="ctr">
+                    <a:lnL w="9525">
+                      <a:solidFill>
+                        <a:srgbClr val="D0D0D0"/>
+                      </a:solidFill>
+                    </a:lnL>
+                    <a:lnR w="9525">
+                      <a:solidFill>
+                        <a:srgbClr val="D0D0D0"/>
+                      </a:solidFill>
+                    </a:lnR>
+                    <a:lnT w="9525">
+                      <a:solidFill>
+                        <a:srgbClr val="D0D0D0"/>
+                      </a:solidFill>
+                    </a:lnT>
+                    <a:lnB w="9525">
+                      <a:solidFill>
+                        <a:srgbClr val="D0D0D0"/>
+                      </a:solidFill>
+                    </a:lnB>
+                    <a:solidFill>
+                      <a:srgbClr val="F1F1F1"/>
+                    </a:solidFill>
+                  </a:tcPr>
+                </a:tc>
+                <a:tc>
+                  <a:txBody>
+                    <a:bodyPr wrap="square"/>
+                    <a:lstStyle/>
+                    <a:p>
+                      <a:r>
+                        <a:rPr sz="1300" b="0">
+                          <a:solidFill>
+                            <a:srgbClr val="2B2B2B"/>
+                          </a:solidFill>
+                          <a:latin typeface="Calibri"/>
+                        </a:rPr>
+                        <a:t>Sep</a:t>
                       </a:r>
                     </a:p>
                   </a:txBody>
@@ -28956,6 +29485,48 @@
                     </a:solidFill>
                   </a:tcPr>
                 </a:tc>
+                <a:tc>
+                  <a:txBody>
+                    <a:bodyPr wrap="square"/>
+                    <a:lstStyle/>
+                    <a:p>
+                      <a:r>
+                        <a:rPr sz="1300" b="0">
+                          <a:solidFill>
+                            <a:srgbClr val="2B2B2B"/>
+                          </a:solidFill>
+                          <a:latin typeface="Calibri"/>
+                        </a:rPr>
+                        <a:t>Sep</a:t>
+                      </a:r>
+                    </a:p>
+                  </a:txBody>
+                  <a:tcPr marL="73152" marR="73152" marT="36576" marB="36576" anchor="ctr">
+                    <a:lnL w="9525">
+                      <a:solidFill>
+                        <a:srgbClr val="D0D0D0"/>
+                      </a:solidFill>
+                    </a:lnL>
+                    <a:lnR w="9525">
+                      <a:solidFill>
+                        <a:srgbClr val="D0D0D0"/>
+                      </a:solidFill>
+                    </a:lnR>
+                    <a:lnT w="9525">
+                      <a:solidFill>
+                        <a:srgbClr val="D0D0D0"/>
+                      </a:solidFill>
+                    </a:lnT>
+                    <a:lnB w="9525">
+                      <a:solidFill>
+                        <a:srgbClr val="D0D0D0"/>
+                      </a:solidFill>
+                    </a:lnB>
+                    <a:solidFill>
+                      <a:srgbClr val="FFFFFF"/>
+                    </a:solidFill>
+                  </a:tcPr>
+                </a:tc>
               </a:tr>
               <a:tr h="658368">
                 <a:tc>
@@ -29055,6 +29626,48 @@
                           <a:latin typeface="Calibri"/>
                         </a:rPr>
                         <a:t>Scale wall layers and time step with particle size</a:t>
+                      </a:r>
+                    </a:p>
+                  </a:txBody>
+                  <a:tcPr marL="73152" marR="73152" marT="36576" marB="36576" anchor="ctr">
+                    <a:lnL w="9525">
+                      <a:solidFill>
+                        <a:srgbClr val="D0D0D0"/>
+                      </a:solidFill>
+                    </a:lnL>
+                    <a:lnR w="9525">
+                      <a:solidFill>
+                        <a:srgbClr val="D0D0D0"/>
+                      </a:solidFill>
+                    </a:lnR>
+                    <a:lnT w="9525">
+                      <a:solidFill>
+                        <a:srgbClr val="D0D0D0"/>
+                      </a:solidFill>
+                    </a:lnT>
+                    <a:lnB w="9525">
+                      <a:solidFill>
+                        <a:srgbClr val="D0D0D0"/>
+                      </a:solidFill>
+                    </a:lnB>
+                    <a:solidFill>
+                      <a:srgbClr val="F1F1F1"/>
+                    </a:solidFill>
+                  </a:tcPr>
+                </a:tc>
+                <a:tc>
+                  <a:txBody>
+                    <a:bodyPr wrap="square"/>
+                    <a:lstStyle/>
+                    <a:p>
+                      <a:r>
+                        <a:rPr sz="1300" b="0">
+                          <a:solidFill>
+                            <a:srgbClr val="2B2B2B"/>
+                          </a:solidFill>
+                          <a:latin typeface="Calibri"/>
+                        </a:rPr>
+                        <a:t>Sep</a:t>
                       </a:r>
                     </a:p>
                   </a:txBody>
@@ -29183,6 +29796,48 @@
                           <a:latin typeface="Calibri"/>
                         </a:rPr>
                         <a:t>Save every 25 steps; skip finished runs</a:t>
+                      </a:r>
+                    </a:p>
+                  </a:txBody>
+                  <a:tcPr marL="73152" marR="73152" marT="36576" marB="36576" anchor="ctr">
+                    <a:lnL w="9525">
+                      <a:solidFill>
+                        <a:srgbClr val="D0D0D0"/>
+                      </a:solidFill>
+                    </a:lnL>
+                    <a:lnR w="9525">
+                      <a:solidFill>
+                        <a:srgbClr val="D0D0D0"/>
+                      </a:solidFill>
+                    </a:lnR>
+                    <a:lnT w="9525">
+                      <a:solidFill>
+                        <a:srgbClr val="D0D0D0"/>
+                      </a:solidFill>
+                    </a:lnT>
+                    <a:lnB w="9525">
+                      <a:solidFill>
+                        <a:srgbClr val="D0D0D0"/>
+                      </a:solidFill>
+                    </a:lnB>
+                    <a:solidFill>
+                      <a:srgbClr val="FFFFFF"/>
+                    </a:solidFill>
+                  </a:tcPr>
+                </a:tc>
+                <a:tc>
+                  <a:txBody>
+                    <a:bodyPr wrap="square"/>
+                    <a:lstStyle/>
+                    <a:p>
+                      <a:r>
+                        <a:rPr sz="1300" b="0">
+                          <a:solidFill>
+                            <a:srgbClr val="2B2B2B"/>
+                          </a:solidFill>
+                          <a:latin typeface="Calibri"/>
+                        </a:rPr>
+                        <a:t>Sep</a:t>
                       </a:r>
                     </a:p>
                   </a:txBody>

</xml_diff>

<commit_message>
Start the presentation timeline in July 2026
</commit_message>
<xml_diff>
--- a/docs/presentation/Liquid_Sloshing_Final_Presentation.pptx
+++ b/docs/presentation/Liquid_Sloshing_Final_Presentation.pptx
@@ -683,7 +683,7 @@
           <a:lstStyle/>
           <a:p>
             <a:r>
-              <a:t>Our methodology has six steps, grouped into design, analysis and validation. We first defined the problem and the tank design. We then built the model: the tank, pivot and motor, the simple pendulum model of the water, and a training environment for the controllers. Next we trained and tuned three controllers on the fast model. We then simulated the real water with SPH on a graphics card at four particle sizes, verified the SPH results against exact answers, and finally compared the controllers in the fully coupled tank. All steps read the same configuration file, so the models can never disagree on a dimension or a mass. The work ran from June to October 2026: design and modelling in June and July, the controllers in July and August, the SPH simulations and checks in August and September, and the two-way comparison, the second-review checks, the paper, the report and this presentation in September and October. A large share of that time went into GPU runs, the longest of which took about nine hours each.</a:t>
+              <a:t>Our methodology has six steps, grouped into design, analysis and validation. We first defined the problem and the tank design. We then built the model: the tank, pivot and motor, the simple pendulum model of the water, and a training environment for the controllers. Next we trained and tuned three controllers on the fast model. We then simulated the real water with SPH on a graphics card at four particle sizes, verified the SPH results against exact answers, and finally compared the controllers in the fully coupled tank. All steps read the same configuration file, so the models can never disagree on a dimension or a mass. The work ran from July to October 2026: design and modelling in July, the controllers in July and August, the SPH simulations and checks in August and September, and the two-way comparison, the second-review checks, the paper, the report and this presentation in September and October. A large share of that time went into GPU runs, the longest of which took about nine hours each.</a:t>
             </a:r>
           </a:p>
         </p:txBody>
@@ -11616,7 +11616,7 @@
                 </a:solidFill>
                 <a:latin typeface="Calibri"/>
               </a:rPr>
-              <a:t>Jun 2026</a:t>
+              <a:t>Jul 2026</a:t>
             </a:r>
           </a:p>
         </p:txBody>
@@ -11843,7 +11843,7 @@
                 </a:solidFill>
                 <a:latin typeface="Calibri"/>
               </a:rPr>
-              <a:t>Jul 2026</a:t>
+              <a:t>Jul – Aug</a:t>
             </a:r>
           </a:p>
         </p:txBody>
@@ -12070,7 +12070,7 @@
                 </a:solidFill>
                 <a:latin typeface="Calibri"/>
               </a:rPr>
-              <a:t>Jul – Aug</a:t>
+              <a:t>Aug</a:t>
             </a:r>
           </a:p>
         </p:txBody>
@@ -12976,7 +12976,7 @@
                 </a:solidFill>
                 <a:latin typeface="Calibri"/>
               </a:rPr>
-              <a:t>June to October 2026, about five months. October: second-review checks, research paper, report and presentation. The finest SPH runs took up to 9 hours each on the GPU.</a:t>
+              <a:t>July to October 2026, about four months. October: second-review checks, research paper, report and presentation. The finest SPH runs took up to 9 hours each on the GPU.</a:t>
             </a:r>
           </a:p>
         </p:txBody>

</xml_diff>

<commit_message>
Start the presentation timeline in June 2026
</commit_message>
<xml_diff>
--- a/docs/presentation/Liquid_Sloshing_Final_Presentation.pptx
+++ b/docs/presentation/Liquid_Sloshing_Final_Presentation.pptx
@@ -683,7 +683,7 @@
           <a:lstStyle/>
           <a:p>
             <a:r>
-              <a:t>Our methodology has six steps, grouped into design, analysis and validation. We first defined the problem and the tank design. We then built the model: the tank, pivot and motor, the simple pendulum model of the water, and a training environment for the controllers. Next we trained and tuned three controllers on the fast model. We then simulated the real water with SPH on a graphics card at four particle sizes, verified the SPH results against exact answers, and finally compared the controllers in the fully coupled tank. All steps read the same configuration file, so the models can never disagree on a dimension or a mass. The work ran from July to October 2026: design and modelling in July, the controllers in July and August, the SPH simulations and checks in August and September, and the two-way comparison, the second-review checks, the paper, the report and this presentation in September and October. A large share of that time went into GPU runs, the longest of which took about nine hours each.</a:t>
+              <a:t>Our methodology has six steps, grouped into design, analysis and validation. We first defined the problem and the tank design. We then built the model: the tank, pivot and motor, the simple pendulum model of the water, and a training environment for the controllers. Next we trained and tuned three controllers on the fast model. We then simulated the real water with SPH on a graphics card at four particle sizes, verified the SPH results against exact answers, and finally compared the controllers in the fully coupled tank. All steps read the same configuration file, so the models can never disagree on a dimension or a mass. The work ran from June to October 2026: design and modelling in June and July, the controllers in July and August, the SPH simulations and checks in August and September, and the two-way comparison, the second-review checks, the paper, the report and this presentation in September and October. A large share of that time went into GPU runs, the longest of which took about nine hours each.</a:t>
             </a:r>
           </a:p>
         </p:txBody>
@@ -11616,7 +11616,7 @@
                 </a:solidFill>
                 <a:latin typeface="Calibri"/>
               </a:rPr>
-              <a:t>Jul 2026</a:t>
+              <a:t>Jun 2026</a:t>
             </a:r>
           </a:p>
         </p:txBody>
@@ -11843,7 +11843,7 @@
                 </a:solidFill>
                 <a:latin typeface="Calibri"/>
               </a:rPr>
-              <a:t>Jul – Aug</a:t>
+              <a:t>Jul 2026</a:t>
             </a:r>
           </a:p>
         </p:txBody>
@@ -12070,7 +12070,7 @@
                 </a:solidFill>
                 <a:latin typeface="Calibri"/>
               </a:rPr>
-              <a:t>Aug</a:t>
+              <a:t>Jul – Aug</a:t>
             </a:r>
           </a:p>
         </p:txBody>
@@ -12976,7 +12976,7 @@
                 </a:solidFill>
                 <a:latin typeface="Calibri"/>
               </a:rPr>
-              <a:t>July to October 2026, about four months. October: second-review checks, research paper, report and presentation. The finest SPH runs took up to 9 hours each on the GPU.</a:t>
+              <a:t>June to October 2026, about five months. October: second-review checks, research paper, report and presentation. The finest SPH runs took up to 9 hours each on the GPU.</a:t>
             </a:r>
           </a:p>
         </p:txBody>

</xml_diff>

<commit_message>
Remove the Housner-masses row from the hand-calculation slide
</commit_message>
<xml_diff>
--- a/docs/presentation/Liquid_Sloshing_Final_Presentation.pptx
+++ b/docs/presentation/Liquid_Sloshing_Final_Presentation.pptx
@@ -17603,7 +17603,7 @@
         </p:nvGraphicFramePr>
         <p:xfrm>
           <a:off x="548640" y="2103120"/>
-          <a:ext cx="11064240" cy="3785616"/>
+          <a:ext cx="11064240" cy="3364992"/>
         </p:xfrm>
         <a:graphic>
           <a:graphicData uri="http://schemas.openxmlformats.org/drawingml/2006/table">
@@ -17970,176 +17970,6 @@
                           </a:solidFill>
                           <a:latin typeface="Calibri"/>
                         </a:rPr>
-                        <a:t>Housner masses and pendulum length</a:t>
-                      </a:r>
-                    </a:p>
-                  </a:txBody>
-                  <a:tcPr marL="73152" marR="73152" marT="36576" marB="36576" anchor="ctr">
-                    <a:lnL w="9525">
-                      <a:solidFill>
-                        <a:srgbClr val="D0D0D0"/>
-                      </a:solidFill>
-                    </a:lnL>
-                    <a:lnR w="9525">
-                      <a:solidFill>
-                        <a:srgbClr val="D0D0D0"/>
-                      </a:solidFill>
-                    </a:lnR>
-                    <a:lnT w="9525">
-                      <a:solidFill>
-                        <a:srgbClr val="D0D0D0"/>
-                      </a:solidFill>
-                    </a:lnT>
-                    <a:lnB w="9525">
-                      <a:solidFill>
-                        <a:srgbClr val="D0D0D0"/>
-                      </a:solidFill>
-                    </a:lnB>
-                    <a:solidFill>
-                      <a:srgbClr val="F1F1F1"/>
-                    </a:solidFill>
-                  </a:tcPr>
-                </a:tc>
-                <a:tc>
-                  <a:txBody>
-                    <a:bodyPr wrap="square"/>
-                    <a:lstStyle/>
-                    <a:p>
-                      <a:r>
-                        <a:rPr sz="1400" b="0">
-                          <a:solidFill>
-                            <a:srgbClr val="2B2B2B"/>
-                          </a:solidFill>
-                          <a:latin typeface="Calibri"/>
-                        </a:rPr>
-                        <a:t>ACI 350.3-06 formulas</a:t>
-                      </a:r>
-                    </a:p>
-                  </a:txBody>
-                  <a:tcPr marL="73152" marR="73152" marT="36576" marB="36576" anchor="ctr">
-                    <a:lnL w="9525">
-                      <a:solidFill>
-                        <a:srgbClr val="D0D0D0"/>
-                      </a:solidFill>
-                    </a:lnL>
-                    <a:lnR w="9525">
-                      <a:solidFill>
-                        <a:srgbClr val="D0D0D0"/>
-                      </a:solidFill>
-                    </a:lnR>
-                    <a:lnT w="9525">
-                      <a:solidFill>
-                        <a:srgbClr val="D0D0D0"/>
-                      </a:solidFill>
-                    </a:lnT>
-                    <a:lnB w="9525">
-                      <a:solidFill>
-                        <a:srgbClr val="D0D0D0"/>
-                      </a:solidFill>
-                    </a:lnB>
-                    <a:solidFill>
-                      <a:srgbClr val="F1F1F1"/>
-                    </a:solidFill>
-                  </a:tcPr>
-                </a:tc>
-                <a:tc>
-                  <a:txBody>
-                    <a:bodyPr wrap="square"/>
-                    <a:lstStyle/>
-                    <a:p>
-                      <a:r>
-                        <a:rPr sz="1400" b="0">
-                          <a:solidFill>
-                            <a:srgbClr val="2B2B2B"/>
-                          </a:solidFill>
-                          <a:latin typeface="Calibri"/>
-                        </a:rPr>
-                        <a:t>Same values in the model</a:t>
-                      </a:r>
-                    </a:p>
-                  </a:txBody>
-                  <a:tcPr marL="73152" marR="73152" marT="36576" marB="36576" anchor="ctr">
-                    <a:lnL w="9525">
-                      <a:solidFill>
-                        <a:srgbClr val="D0D0D0"/>
-                      </a:solidFill>
-                    </a:lnL>
-                    <a:lnR w="9525">
-                      <a:solidFill>
-                        <a:srgbClr val="D0D0D0"/>
-                      </a:solidFill>
-                    </a:lnR>
-                    <a:lnT w="9525">
-                      <a:solidFill>
-                        <a:srgbClr val="D0D0D0"/>
-                      </a:solidFill>
-                    </a:lnT>
-                    <a:lnB w="9525">
-                      <a:solidFill>
-                        <a:srgbClr val="D0D0D0"/>
-                      </a:solidFill>
-                    </a:lnB>
-                    <a:solidFill>
-                      <a:srgbClr val="F1F1F1"/>
-                    </a:solidFill>
-                  </a:tcPr>
-                </a:tc>
-                <a:tc>
-                  <a:txBody>
-                    <a:bodyPr wrap="square"/>
-                    <a:lstStyle/>
-                    <a:p>
-                      <a:r>
-                        <a:rPr sz="1400" b="0">
-                          <a:solidFill>
-                            <a:srgbClr val="2B2B2B"/>
-                          </a:solidFill>
-                          <a:latin typeface="Calibri"/>
-                        </a:rPr>
-                        <a:t>0.00%</a:t>
-                      </a:r>
-                    </a:p>
-                  </a:txBody>
-                  <a:tcPr marL="73152" marR="73152" marT="36576" marB="36576" anchor="ctr">
-                    <a:lnL w="9525">
-                      <a:solidFill>
-                        <a:srgbClr val="D0D0D0"/>
-                      </a:solidFill>
-                    </a:lnL>
-                    <a:lnR w="9525">
-                      <a:solidFill>
-                        <a:srgbClr val="D0D0D0"/>
-                      </a:solidFill>
-                    </a:lnR>
-                    <a:lnT w="9525">
-                      <a:solidFill>
-                        <a:srgbClr val="D0D0D0"/>
-                      </a:solidFill>
-                    </a:lnT>
-                    <a:lnB w="9525">
-                      <a:solidFill>
-                        <a:srgbClr val="D0D0D0"/>
-                      </a:solidFill>
-                    </a:lnB>
-                    <a:solidFill>
-                      <a:srgbClr val="F1F1F1"/>
-                    </a:solidFill>
-                  </a:tcPr>
-                </a:tc>
-              </a:tr>
-              <a:tr h="420624">
-                <a:tc>
-                  <a:txBody>
-                    <a:bodyPr wrap="square"/>
-                    <a:lstStyle/>
-                    <a:p>
-                      <a:r>
-                        <a:rPr sz="1400" b="1">
-                          <a:solidFill>
-                            <a:srgbClr val="2B2B2B"/>
-                          </a:solidFill>
-                          <a:latin typeface="Calibri"/>
-                        </a:rPr>
                         <a:t>Pendulum sloshing frequency</a:t>
                       </a:r>
                     </a:p>
@@ -18166,7 +17996,7 @@
                       </a:solidFill>
                     </a:lnB>
                     <a:solidFill>
-                      <a:srgbClr val="FFFFFF"/>
+                      <a:srgbClr val="F1F1F1"/>
                     </a:solidFill>
                   </a:tcPr>
                 </a:tc>
@@ -18208,7 +18038,7 @@
                       </a:solidFill>
                     </a:lnB>
                     <a:solidFill>
-                      <a:srgbClr val="FFFFFF"/>
+                      <a:srgbClr val="F1F1F1"/>
                     </a:solidFill>
                   </a:tcPr>
                 </a:tc>
@@ -18250,7 +18080,7 @@
                       </a:solidFill>
                     </a:lnB>
                     <a:solidFill>
-                      <a:srgbClr val="FFFFFF"/>
+                      <a:srgbClr val="F1F1F1"/>
                     </a:solidFill>
                   </a:tcPr>
                 </a:tc>
@@ -18292,7 +18122,7 @@
                       </a:solidFill>
                     </a:lnB>
                     <a:solidFill>
-                      <a:srgbClr val="FFFFFF"/>
+                      <a:srgbClr val="F1F1F1"/>
                     </a:solidFill>
                   </a:tcPr>
                 </a:tc>
@@ -18336,7 +18166,7 @@
                       </a:solidFill>
                     </a:lnB>
                     <a:solidFill>
-                      <a:srgbClr val="F1F1F1"/>
+                      <a:srgbClr val="FFFFFF"/>
                     </a:solidFill>
                   </a:tcPr>
                 </a:tc>
@@ -18378,7 +18208,7 @@
                       </a:solidFill>
                     </a:lnB>
                     <a:solidFill>
-                      <a:srgbClr val="F1F1F1"/>
+                      <a:srgbClr val="FFFFFF"/>
                     </a:solidFill>
                   </a:tcPr>
                 </a:tc>
@@ -18420,7 +18250,7 @@
                       </a:solidFill>
                     </a:lnB>
                     <a:solidFill>
-                      <a:srgbClr val="F1F1F1"/>
+                      <a:srgbClr val="FFFFFF"/>
                     </a:solidFill>
                   </a:tcPr>
                 </a:tc>
@@ -18462,7 +18292,7 @@
                       </a:solidFill>
                     </a:lnB>
                     <a:solidFill>
-                      <a:srgbClr val="F1F1F1"/>
+                      <a:srgbClr val="FFFFFF"/>
                     </a:solidFill>
                   </a:tcPr>
                 </a:tc>
@@ -18506,7 +18336,7 @@
                       </a:solidFill>
                     </a:lnB>
                     <a:solidFill>
-                      <a:srgbClr val="FFFFFF"/>
+                      <a:srgbClr val="F1F1F1"/>
                     </a:solidFill>
                   </a:tcPr>
                 </a:tc>
@@ -18548,7 +18378,7 @@
                       </a:solidFill>
                     </a:lnB>
                     <a:solidFill>
-                      <a:srgbClr val="FFFFFF"/>
+                      <a:srgbClr val="F1F1F1"/>
                     </a:solidFill>
                   </a:tcPr>
                 </a:tc>
@@ -18590,7 +18420,7 @@
                       </a:solidFill>
                     </a:lnB>
                     <a:solidFill>
-                      <a:srgbClr val="FFFFFF"/>
+                      <a:srgbClr val="F1F1F1"/>
                     </a:solidFill>
                   </a:tcPr>
                 </a:tc>
@@ -18632,7 +18462,7 @@
                       </a:solidFill>
                     </a:lnB>
                     <a:solidFill>
-                      <a:srgbClr val="FFFFFF"/>
+                      <a:srgbClr val="F1F1F1"/>
                     </a:solidFill>
                   </a:tcPr>
                 </a:tc>
@@ -18676,7 +18506,7 @@
                       </a:solidFill>
                     </a:lnB>
                     <a:solidFill>
-                      <a:srgbClr val="F1F1F1"/>
+                      <a:srgbClr val="FFFFFF"/>
                     </a:solidFill>
                   </a:tcPr>
                 </a:tc>
@@ -18718,7 +18548,7 @@
                       </a:solidFill>
                     </a:lnB>
                     <a:solidFill>
-                      <a:srgbClr val="F1F1F1"/>
+                      <a:srgbClr val="FFFFFF"/>
                     </a:solidFill>
                   </a:tcPr>
                 </a:tc>
@@ -18760,7 +18590,7 @@
                       </a:solidFill>
                     </a:lnB>
                     <a:solidFill>
-                      <a:srgbClr val="F1F1F1"/>
+                      <a:srgbClr val="FFFFFF"/>
                     </a:solidFill>
                   </a:tcPr>
                 </a:tc>
@@ -18802,7 +18632,7 @@
                       </a:solidFill>
                     </a:lnB>
                     <a:solidFill>
-                      <a:srgbClr val="F1F1F1"/>
+                      <a:srgbClr val="FFFFFF"/>
                     </a:solidFill>
                   </a:tcPr>
                 </a:tc>
@@ -18846,6 +18676,176 @@
                       </a:solidFill>
                     </a:lnB>
                     <a:solidFill>
+                      <a:srgbClr val="F1F1F1"/>
+                    </a:solidFill>
+                  </a:tcPr>
+                </a:tc>
+                <a:tc>
+                  <a:txBody>
+                    <a:bodyPr wrap="square"/>
+                    <a:lstStyle/>
+                    <a:p>
+                      <a:r>
+                        <a:rPr sz="1400" b="0">
+                          <a:solidFill>
+                            <a:srgbClr val="2B2B2B"/>
+                          </a:solidFill>
+                          <a:latin typeface="Calibri"/>
+                        </a:rPr>
+                        <a:t>Fr = 0.054 (gentle, linear sloshing)</a:t>
+                      </a:r>
+                    </a:p>
+                  </a:txBody>
+                  <a:tcPr marL="73152" marR="73152" marT="36576" marB="36576" anchor="ctr">
+                    <a:lnL w="9525">
+                      <a:solidFill>
+                        <a:srgbClr val="D0D0D0"/>
+                      </a:solidFill>
+                    </a:lnL>
+                    <a:lnR w="9525">
+                      <a:solidFill>
+                        <a:srgbClr val="D0D0D0"/>
+                      </a:solidFill>
+                    </a:lnR>
+                    <a:lnT w="9525">
+                      <a:solidFill>
+                        <a:srgbClr val="D0D0D0"/>
+                      </a:solidFill>
+                    </a:lnT>
+                    <a:lnB w="9525">
+                      <a:solidFill>
+                        <a:srgbClr val="D0D0D0"/>
+                      </a:solidFill>
+                    </a:lnB>
+                    <a:solidFill>
+                      <a:srgbClr val="F1F1F1"/>
+                    </a:solidFill>
+                  </a:tcPr>
+                </a:tc>
+                <a:tc>
+                  <a:txBody>
+                    <a:bodyPr wrap="square"/>
+                    <a:lstStyle/>
+                    <a:p>
+                      <a:r>
+                        <a:rPr sz="1400" b="0">
+                          <a:solidFill>
+                            <a:srgbClr val="2B2B2B"/>
+                          </a:solidFill>
+                          <a:latin typeface="Calibri"/>
+                        </a:rPr>
+                        <a:t>Same value</a:t>
+                      </a:r>
+                    </a:p>
+                  </a:txBody>
+                  <a:tcPr marL="73152" marR="73152" marT="36576" marB="36576" anchor="ctr">
+                    <a:lnL w="9525">
+                      <a:solidFill>
+                        <a:srgbClr val="D0D0D0"/>
+                      </a:solidFill>
+                    </a:lnL>
+                    <a:lnR w="9525">
+                      <a:solidFill>
+                        <a:srgbClr val="D0D0D0"/>
+                      </a:solidFill>
+                    </a:lnR>
+                    <a:lnT w="9525">
+                      <a:solidFill>
+                        <a:srgbClr val="D0D0D0"/>
+                      </a:solidFill>
+                    </a:lnT>
+                    <a:lnB w="9525">
+                      <a:solidFill>
+                        <a:srgbClr val="D0D0D0"/>
+                      </a:solidFill>
+                    </a:lnB>
+                    <a:solidFill>
+                      <a:srgbClr val="F1F1F1"/>
+                    </a:solidFill>
+                  </a:tcPr>
+                </a:tc>
+                <a:tc>
+                  <a:txBody>
+                    <a:bodyPr wrap="square"/>
+                    <a:lstStyle/>
+                    <a:p>
+                      <a:r>
+                        <a:rPr sz="1400" b="0">
+                          <a:solidFill>
+                            <a:srgbClr val="2B2B2B"/>
+                          </a:solidFill>
+                          <a:latin typeface="Calibri"/>
+                        </a:rPr>
+                        <a:t>—</a:t>
+                      </a:r>
+                    </a:p>
+                  </a:txBody>
+                  <a:tcPr marL="73152" marR="73152" marT="36576" marB="36576" anchor="ctr">
+                    <a:lnL w="9525">
+                      <a:solidFill>
+                        <a:srgbClr val="D0D0D0"/>
+                      </a:solidFill>
+                    </a:lnL>
+                    <a:lnR w="9525">
+                      <a:solidFill>
+                        <a:srgbClr val="D0D0D0"/>
+                      </a:solidFill>
+                    </a:lnR>
+                    <a:lnT w="9525">
+                      <a:solidFill>
+                        <a:srgbClr val="D0D0D0"/>
+                      </a:solidFill>
+                    </a:lnT>
+                    <a:lnB w="9525">
+                      <a:solidFill>
+                        <a:srgbClr val="D0D0D0"/>
+                      </a:solidFill>
+                    </a:lnB>
+                    <a:solidFill>
+                      <a:srgbClr val="F1F1F1"/>
+                    </a:solidFill>
+                  </a:tcPr>
+                </a:tc>
+              </a:tr>
+              <a:tr h="420624">
+                <a:tc>
+                  <a:txBody>
+                    <a:bodyPr wrap="square"/>
+                    <a:lstStyle/>
+                    <a:p>
+                      <a:r>
+                        <a:rPr sz="1400" b="1">
+                          <a:solidFill>
+                            <a:srgbClr val="2B2B2B"/>
+                          </a:solidFill>
+                          <a:latin typeface="Calibri"/>
+                        </a:rPr>
+                        <a:t>Reynolds number</a:t>
+                      </a:r>
+                    </a:p>
+                  </a:txBody>
+                  <a:tcPr marL="73152" marR="73152" marT="36576" marB="36576" anchor="ctr">
+                    <a:lnL w="9525">
+                      <a:solidFill>
+                        <a:srgbClr val="D0D0D0"/>
+                      </a:solidFill>
+                    </a:lnL>
+                    <a:lnR w="9525">
+                      <a:solidFill>
+                        <a:srgbClr val="D0D0D0"/>
+                      </a:solidFill>
+                    </a:lnR>
+                    <a:lnT w="9525">
+                      <a:solidFill>
+                        <a:srgbClr val="D0D0D0"/>
+                      </a:solidFill>
+                    </a:lnT>
+                    <a:lnB w="9525">
+                      <a:solidFill>
+                        <a:srgbClr val="D0D0D0"/>
+                      </a:solidFill>
+                    </a:lnB>
+                    <a:solidFill>
                       <a:srgbClr val="FFFFFF"/>
                     </a:solidFill>
                   </a:tcPr>
@@ -18862,7 +18862,7 @@
                           </a:solidFill>
                           <a:latin typeface="Calibri"/>
                         </a:rPr>
-                        <a:t>Fr = 0.054 (gentle, linear sloshing)</a:t>
+                        <a:t>Re ≈ 7.7 × 10⁴</a:t>
                       </a:r>
                     </a:p>
                   </a:txBody>
@@ -18973,176 +18973,6 @@
                     </a:lnB>
                     <a:solidFill>
                       <a:srgbClr val="FFFFFF"/>
-                    </a:solidFill>
-                  </a:tcPr>
-                </a:tc>
-              </a:tr>
-              <a:tr h="420624">
-                <a:tc>
-                  <a:txBody>
-                    <a:bodyPr wrap="square"/>
-                    <a:lstStyle/>
-                    <a:p>
-                      <a:r>
-                        <a:rPr sz="1400" b="1">
-                          <a:solidFill>
-                            <a:srgbClr val="2B2B2B"/>
-                          </a:solidFill>
-                          <a:latin typeface="Calibri"/>
-                        </a:rPr>
-                        <a:t>Reynolds number</a:t>
-                      </a:r>
-                    </a:p>
-                  </a:txBody>
-                  <a:tcPr marL="73152" marR="73152" marT="36576" marB="36576" anchor="ctr">
-                    <a:lnL w="9525">
-                      <a:solidFill>
-                        <a:srgbClr val="D0D0D0"/>
-                      </a:solidFill>
-                    </a:lnL>
-                    <a:lnR w="9525">
-                      <a:solidFill>
-                        <a:srgbClr val="D0D0D0"/>
-                      </a:solidFill>
-                    </a:lnR>
-                    <a:lnT w="9525">
-                      <a:solidFill>
-                        <a:srgbClr val="D0D0D0"/>
-                      </a:solidFill>
-                    </a:lnT>
-                    <a:lnB w="9525">
-                      <a:solidFill>
-                        <a:srgbClr val="D0D0D0"/>
-                      </a:solidFill>
-                    </a:lnB>
-                    <a:solidFill>
-                      <a:srgbClr val="F1F1F1"/>
-                    </a:solidFill>
-                  </a:tcPr>
-                </a:tc>
-                <a:tc>
-                  <a:txBody>
-                    <a:bodyPr wrap="square"/>
-                    <a:lstStyle/>
-                    <a:p>
-                      <a:r>
-                        <a:rPr sz="1400" b="0">
-                          <a:solidFill>
-                            <a:srgbClr val="2B2B2B"/>
-                          </a:solidFill>
-                          <a:latin typeface="Calibri"/>
-                        </a:rPr>
-                        <a:t>Re ≈ 7.7 × 10⁴</a:t>
-                      </a:r>
-                    </a:p>
-                  </a:txBody>
-                  <a:tcPr marL="73152" marR="73152" marT="36576" marB="36576" anchor="ctr">
-                    <a:lnL w="9525">
-                      <a:solidFill>
-                        <a:srgbClr val="D0D0D0"/>
-                      </a:solidFill>
-                    </a:lnL>
-                    <a:lnR w="9525">
-                      <a:solidFill>
-                        <a:srgbClr val="D0D0D0"/>
-                      </a:solidFill>
-                    </a:lnR>
-                    <a:lnT w="9525">
-                      <a:solidFill>
-                        <a:srgbClr val="D0D0D0"/>
-                      </a:solidFill>
-                    </a:lnT>
-                    <a:lnB w="9525">
-                      <a:solidFill>
-                        <a:srgbClr val="D0D0D0"/>
-                      </a:solidFill>
-                    </a:lnB>
-                    <a:solidFill>
-                      <a:srgbClr val="F1F1F1"/>
-                    </a:solidFill>
-                  </a:tcPr>
-                </a:tc>
-                <a:tc>
-                  <a:txBody>
-                    <a:bodyPr wrap="square"/>
-                    <a:lstStyle/>
-                    <a:p>
-                      <a:r>
-                        <a:rPr sz="1400" b="0">
-                          <a:solidFill>
-                            <a:srgbClr val="2B2B2B"/>
-                          </a:solidFill>
-                          <a:latin typeface="Calibri"/>
-                        </a:rPr>
-                        <a:t>Same value</a:t>
-                      </a:r>
-                    </a:p>
-                  </a:txBody>
-                  <a:tcPr marL="73152" marR="73152" marT="36576" marB="36576" anchor="ctr">
-                    <a:lnL w="9525">
-                      <a:solidFill>
-                        <a:srgbClr val="D0D0D0"/>
-                      </a:solidFill>
-                    </a:lnL>
-                    <a:lnR w="9525">
-                      <a:solidFill>
-                        <a:srgbClr val="D0D0D0"/>
-                      </a:solidFill>
-                    </a:lnR>
-                    <a:lnT w="9525">
-                      <a:solidFill>
-                        <a:srgbClr val="D0D0D0"/>
-                      </a:solidFill>
-                    </a:lnT>
-                    <a:lnB w="9525">
-                      <a:solidFill>
-                        <a:srgbClr val="D0D0D0"/>
-                      </a:solidFill>
-                    </a:lnB>
-                    <a:solidFill>
-                      <a:srgbClr val="F1F1F1"/>
-                    </a:solidFill>
-                  </a:tcPr>
-                </a:tc>
-                <a:tc>
-                  <a:txBody>
-                    <a:bodyPr wrap="square"/>
-                    <a:lstStyle/>
-                    <a:p>
-                      <a:r>
-                        <a:rPr sz="1400" b="0">
-                          <a:solidFill>
-                            <a:srgbClr val="2B2B2B"/>
-                          </a:solidFill>
-                          <a:latin typeface="Calibri"/>
-                        </a:rPr>
-                        <a:t>—</a:t>
-                      </a:r>
-                    </a:p>
-                  </a:txBody>
-                  <a:tcPr marL="73152" marR="73152" marT="36576" marB="36576" anchor="ctr">
-                    <a:lnL w="9525">
-                      <a:solidFill>
-                        <a:srgbClr val="D0D0D0"/>
-                      </a:solidFill>
-                    </a:lnL>
-                    <a:lnR w="9525">
-                      <a:solidFill>
-                        <a:srgbClr val="D0D0D0"/>
-                      </a:solidFill>
-                    </a:lnR>
-                    <a:lnT w="9525">
-                      <a:solidFill>
-                        <a:srgbClr val="D0D0D0"/>
-                      </a:solidFill>
-                    </a:lnT>
-                    <a:lnB w="9525">
-                      <a:solidFill>
-                        <a:srgbClr val="D0D0D0"/>
-                      </a:solidFill>
-                    </a:lnB>
-                    <a:solidFill>
-                      <a:srgbClr val="F1F1F1"/>
                     </a:solidFill>
                   </a:tcPr>
                 </a:tc>

</xml_diff>

<commit_message>
Update the architecture diagram in the presentation
</commit_message>
<xml_diff>
--- a/docs/presentation/Liquid_Sloshing_Final_Presentation.pptx
+++ b/docs/presentation/Liquid_Sloshing_Final_Presentation.pptx
@@ -17319,7 +17319,7 @@
       </p:sp>
       <p:pic>
         <p:nvPicPr>
-          <p:cNvPr id="4" name="Picture 3" descr="arch_crop.png"/>
+          <p:cNvPr id="4" name="Picture 3" descr="arch_new.png"/>
           <p:cNvPicPr>
             <a:picLocks noChangeAspect="1"/>
           </p:cNvPicPr>
@@ -17333,8 +17333,8 @@
         </p:blipFill>
         <p:spPr>
           <a:xfrm>
-            <a:off x="1254831" y="1783080"/>
-            <a:ext cx="9651857" cy="4069080"/>
+            <a:off x="1218209" y="1783080"/>
+            <a:ext cx="9725101" cy="4069080"/>
           </a:xfrm>
           <a:prstGeom prst="rect">
             <a:avLst/>

</xml_diff>

<commit_message>
Move the interactive-simulations slide to slide 25
</commit_message>
<xml_diff>
--- a/docs/presentation/Liquid_Sloshing_Final_Presentation.pptx
+++ b/docs/presentation/Liquid_Sloshing_Final_Presentation.pptx
@@ -29,11 +29,11 @@
     <p:sldId id="287" r:id="rId38"/>
     <p:sldId id="288" r:id="rId39"/>
     <p:sldId id="289" r:id="rId40"/>
+    <p:sldId id="301" r:id="rId52"/>
     <p:sldId id="293" r:id="rId44"/>
     <p:sldId id="294" r:id="rId45"/>
     <p:sldId id="296" r:id="rId47"/>
     <p:sldId id="298" r:id="rId49"/>
-    <p:sldId id="301" r:id="rId52"/>
     <p:sldId id="302" r:id="rId53"/>
     <p:sldId id="305" r:id="rId56"/>
     <p:sldId id="306" r:id="rId57"/>
@@ -25838,7 +25838,7 @@
                 </a:solidFill>
                 <a:latin typeface="Calibri"/>
               </a:rPr>
-              <a:t>25</a:t>
+              <a:t>26</a:t>
             </a:r>
           </a:p>
         </p:txBody>
@@ -26075,7 +26075,7 @@
                 </a:solidFill>
                 <a:latin typeface="Calibri"/>
               </a:rPr>
-              <a:t>26</a:t>
+              <a:t>27</a:t>
             </a:r>
           </a:p>
         </p:txBody>
@@ -26537,7 +26537,7 @@
                 </a:solidFill>
                 <a:latin typeface="Calibri"/>
               </a:rPr>
-              <a:t>27</a:t>
+              <a:t>28</a:t>
             </a:r>
           </a:p>
         </p:txBody>
@@ -27852,7 +27852,7 @@
                 </a:solidFill>
                 <a:latin typeface="Calibri"/>
               </a:rPr>
-              <a:t>28</a:t>
+              <a:t>29</a:t>
             </a:r>
           </a:p>
         </p:txBody>
@@ -28514,7 +28514,7 @@
                 </a:solidFill>
                 <a:latin typeface="Calibri"/>
               </a:rPr>
-              <a:t>29</a:t>
+              <a:t>25</a:t>
             </a:r>
           </a:p>
         </p:txBody>

</xml_diff>

<commit_message>
Show only the 3D lab on the interactive-simulations slide
</commit_message>
<xml_diff>
--- a/docs/presentation/Liquid_Sloshing_Final_Presentation.pptx
+++ b/docs/presentation/Liquid_Sloshing_Final_Presentation.pptx
@@ -2153,7 +2153,7 @@
           <a:lstStyle/>
           <a:p>
             <a:r>
-              <a:t>Everything we have shown can also be explored interactively in a web browser. The 3D Sloshing Lab replays the real SPH water inside the tilting tank, lets you drive the tank yourself, shows the tank on a truck bed over a bumpy road, and compares the four particle sizes. The interactive report has a live demo where you set the motor torque, kick the water and try to calm it yourself, along with all our results. Both open directly from our presentation folder in any web browser, and need no internet connection.</a:t>
+              <a:t>Everything we have shown can also be explored interactively in a web browser. The 3D Sloshing Lab replays the real SPH water inside the tilting tank, lets you drive the tank yourself, shows the tank on a truck bed over a bumpy road, and compares the four particle sizes. It opens directly from our presentation folder in any web browser, and needs no internet connection.</a:t>
             </a:r>
           </a:p>
         </p:txBody>
@@ -27948,7 +27948,7 @@
                 </a:solidFill>
                 <a:latin typeface="Calibri"/>
               </a:rPr>
-              <a:t>Click to open our live simulations in a web browser</a:t>
+              <a:t>Click to open our live 3D simulation in a web browser</a:t>
             </a:r>
           </a:p>
         </p:txBody>
@@ -27962,7 +27962,7 @@
         <p:spPr>
           <a:xfrm>
             <a:off x="548640" y="1783080"/>
-            <a:ext cx="5440680" cy="594360"/>
+            <a:ext cx="11064240" cy="594360"/>
           </a:xfrm>
           <a:prstGeom prst="roundRect">
             <a:avLst>
@@ -28021,7 +28021,7 @@
         <p:spPr>
           <a:xfrm>
             <a:off x="548640" y="2468880"/>
-            <a:ext cx="5440680" cy="2880360"/>
+            <a:ext cx="11064240" cy="2103120"/>
           </a:xfrm>
           <a:prstGeom prst="roundRect">
             <a:avLst>
@@ -28051,17 +28051,17 @@
           </a:fontRef>
         </p:style>
         <p:txBody>
-          <a:bodyPr rtlCol="0" anchor="t" lIns="228600" rIns="228600" tIns="228600" bIns="228600" wrap="square"/>
+          <a:bodyPr rtlCol="0" anchor="t" lIns="274320" rIns="274320" tIns="274320" bIns="274320" wrap="square"/>
           <a:lstStyle/>
           <a:p>
             <a:pPr algn="l" marL="201168" indent="-182880">
               <a:spcAft>
-                <a:spcPts val="800"/>
+                <a:spcPts val="1000"/>
               </a:spcAft>
               <a:buChar char="•"/>
             </a:pPr>
             <a:r>
-              <a:rPr sz="1500" b="0" i="0">
+              <a:rPr sz="1600" b="0" i="0">
                 <a:solidFill>
                   <a:srgbClr val="2B2B2B"/>
                 </a:solidFill>
@@ -28073,12 +28073,12 @@
           <a:p>
             <a:pPr algn="l" marL="201168" indent="-182880">
               <a:spcAft>
-                <a:spcPts val="800"/>
+                <a:spcPts val="1000"/>
               </a:spcAft>
               <a:buChar char="•"/>
             </a:pPr>
             <a:r>
-              <a:rPr sz="1500" b="0" i="0">
+              <a:rPr sz="1600" b="0" i="0">
                 <a:solidFill>
                   <a:srgbClr val="2B2B2B"/>
                 </a:solidFill>
@@ -28090,12 +28090,12 @@
           <a:p>
             <a:pPr algn="l" marL="201168" indent="-182880">
               <a:spcAft>
-                <a:spcPts val="800"/>
+                <a:spcPts val="1000"/>
               </a:spcAft>
               <a:buChar char="•"/>
             </a:pPr>
             <a:r>
-              <a:rPr sz="1500" b="0" i="0">
+              <a:rPr sz="1600" b="0" i="0">
                 <a:solidFill>
                   <a:srgbClr val="2B2B2B"/>
                 </a:solidFill>
@@ -28107,12 +28107,12 @@
           <a:p>
             <a:pPr algn="l" marL="201168" indent="-182880">
               <a:spcAft>
-                <a:spcPts val="800"/>
+                <a:spcPts val="1000"/>
               </a:spcAft>
               <a:buChar char="•"/>
             </a:pPr>
             <a:r>
-              <a:rPr sz="1500" b="0" i="0">
+              <a:rPr sz="1600" b="0" i="0">
                 <a:solidFill>
                   <a:srgbClr val="2B2B2B"/>
                 </a:solidFill>
@@ -28131,8 +28131,8 @@
         </p:nvSpPr>
         <p:spPr>
           <a:xfrm>
-            <a:off x="548640" y="5440680"/>
-            <a:ext cx="5440680" cy="457200"/>
+            <a:off x="548640" y="4709160"/>
+            <a:ext cx="11064240" cy="457200"/>
           </a:xfrm>
           <a:prstGeom prst="rect">
             <a:avLst/>
@@ -28166,8 +28166,8 @@
         </p:nvSpPr>
         <p:spPr>
           <a:xfrm>
-            <a:off x="548640" y="5870448"/>
-            <a:ext cx="5440680" cy="365760"/>
+            <a:off x="548640" y="5138928"/>
+            <a:ext cx="11064240" cy="365760"/>
           </a:xfrm>
           <a:prstGeom prst="rect">
             <a:avLst/>
@@ -28199,251 +28199,7 @@
       </p:sp>
       <p:sp>
         <p:nvSpPr>
-          <p:cNvPr id="8" name="Rounded Rectangle 7"/>
-          <p:cNvSpPr/>
-          <p:nvPr/>
-        </p:nvSpPr>
-        <p:spPr>
-          <a:xfrm>
-            <a:off x="6172200" y="1783080"/>
-            <a:ext cx="5440680" cy="594360"/>
-          </a:xfrm>
-          <a:prstGeom prst="roundRect">
-            <a:avLst>
-              <a:gd name="adj" fmla="val 8000"/>
-            </a:avLst>
-          </a:prstGeom>
-          <a:solidFill>
-            <a:srgbClr val="2B2B2B"/>
-          </a:solidFill>
-          <a:ln>
-            <a:noFill/>
-          </a:ln>
-          <a:effectLst/>
-        </p:spPr>
-        <p:style>
-          <a:lnRef idx="1">
-            <a:schemeClr val="accent1"/>
-          </a:lnRef>
-          <a:fillRef idx="3">
-            <a:schemeClr val="accent1"/>
-          </a:fillRef>
-          <a:effectRef idx="2">
-            <a:schemeClr val="accent1"/>
-          </a:effectRef>
-          <a:fontRef idx="minor">
-            <a:schemeClr val="lt1"/>
-          </a:fontRef>
-        </p:style>
-        <p:txBody>
-          <a:bodyPr rtlCol="0" anchor="ctr" lIns="182880" rIns="182880" tIns="182880" bIns="182880" wrap="square"/>
-          <a:lstStyle/>
-          <a:p>
-            <a:pPr algn="l">
-              <a:spcAft>
-                <a:spcPts val="400"/>
-              </a:spcAft>
-            </a:pPr>
-            <a:r>
-              <a:rPr sz="1900" b="1" i="0">
-                <a:solidFill>
-                  <a:srgbClr val="FFFFFF"/>
-                </a:solidFill>
-                <a:latin typeface="Calibri"/>
-              </a:rPr>
-              <a:t>Interactive Project Report</a:t>
-            </a:r>
-          </a:p>
-        </p:txBody>
-      </p:sp>
-      <p:sp>
-        <p:nvSpPr>
-          <p:cNvPr id="9" name="Rounded Rectangle 8"/>
-          <p:cNvSpPr/>
-          <p:nvPr/>
-        </p:nvSpPr>
-        <p:spPr>
-          <a:xfrm>
-            <a:off x="6172200" y="2468880"/>
-            <a:ext cx="5440680" cy="2880360"/>
-          </a:xfrm>
-          <a:prstGeom prst="roundRect">
-            <a:avLst>
-              <a:gd name="adj" fmla="val 8000"/>
-            </a:avLst>
-          </a:prstGeom>
-          <a:solidFill>
-            <a:srgbClr val="F1F1F1"/>
-          </a:solidFill>
-          <a:ln>
-            <a:noFill/>
-          </a:ln>
-          <a:effectLst/>
-        </p:spPr>
-        <p:style>
-          <a:lnRef idx="1">
-            <a:schemeClr val="accent1"/>
-          </a:lnRef>
-          <a:fillRef idx="3">
-            <a:schemeClr val="accent1"/>
-          </a:fillRef>
-          <a:effectRef idx="2">
-            <a:schemeClr val="accent1"/>
-          </a:effectRef>
-          <a:fontRef idx="minor">
-            <a:schemeClr val="lt1"/>
-          </a:fontRef>
-        </p:style>
-        <p:txBody>
-          <a:bodyPr rtlCol="0" anchor="t" lIns="228600" rIns="228600" tIns="228600" bIns="228600" wrap="square"/>
-          <a:lstStyle/>
-          <a:p>
-            <a:pPr algn="l" marL="201168" indent="-182880">
-              <a:spcAft>
-                <a:spcPts val="800"/>
-              </a:spcAft>
-              <a:buChar char="•"/>
-            </a:pPr>
-            <a:r>
-              <a:rPr sz="1500" b="0" i="0">
-                <a:solidFill>
-                  <a:srgbClr val="2B2B2B"/>
-                </a:solidFill>
-                <a:latin typeface="Calibri"/>
-              </a:rPr>
-              <a:t>Live demo: set the motor torque, press “Kick it”, and try to calm the water</a:t>
-            </a:r>
-          </a:p>
-          <a:p>
-            <a:pPr algn="l" marL="201168" indent="-182880">
-              <a:spcAft>
-                <a:spcPts val="800"/>
-              </a:spcAft>
-              <a:buChar char="•"/>
-            </a:pPr>
-            <a:r>
-              <a:rPr sz="1500" b="0" i="0">
-                <a:solidFill>
-                  <a:srgbClr val="2B2B2B"/>
-                </a:solidFill>
-                <a:latin typeface="Calibri"/>
-              </a:rPr>
-              <a:t>Validation of the fluid model against real SPH</a:t>
-            </a:r>
-          </a:p>
-          <a:p>
-            <a:pPr algn="l" marL="201168" indent="-182880">
-              <a:spcAft>
-                <a:spcPts val="800"/>
-              </a:spcAft>
-              <a:buChar char="•"/>
-            </a:pPr>
-            <a:r>
-              <a:rPr sz="1500" b="0" i="0">
-                <a:solidFill>
-                  <a:srgbClr val="2B2B2B"/>
-                </a:solidFill>
-                <a:latin typeface="Calibri"/>
-              </a:rPr>
-              <a:t>Closed-loop results on real fluid, every key number</a:t>
-            </a:r>
-          </a:p>
-          <a:p>
-            <a:pPr algn="l" marL="201168" indent="-182880">
-              <a:spcAft>
-                <a:spcPts val="800"/>
-              </a:spcAft>
-              <a:buChar char="•"/>
-            </a:pPr>
-            <a:r>
-              <a:rPr sz="1500" b="0" i="0">
-                <a:solidFill>
-                  <a:srgbClr val="2B2B2B"/>
-                </a:solidFill>
-                <a:latin typeface="Calibri"/>
-              </a:rPr>
-              <a:t>Answers to the second review</a:t>
-            </a:r>
-          </a:p>
-        </p:txBody>
-      </p:sp>
-      <p:sp>
-        <p:nvSpPr>
-          <p:cNvPr id="10" name="TextBox 9"/>
-          <p:cNvSpPr txBox="1"/>
-          <p:nvPr/>
-        </p:nvSpPr>
-        <p:spPr>
-          <a:xfrm>
-            <a:off x="6172200" y="5440680"/>
-            <a:ext cx="5440680" cy="457200"/>
-          </a:xfrm>
-          <a:prstGeom prst="rect">
-            <a:avLst/>
-          </a:prstGeom>
-          <a:noFill/>
-        </p:spPr>
-        <p:txBody>
-          <a:bodyPr wrap="square">
-            <a:spAutoFit/>
-          </a:bodyPr>
-          <a:lstStyle/>
-          <a:p>
-            <a:r>
-              <a:rPr sz="1500" b="1">
-                <a:solidFill>
-                  <a:srgbClr val="1F5F86"/>
-                </a:solidFill>
-                <a:latin typeface="Calibri"/>
-                <a:hlinkClick r:id="rId3"/>
-              </a:rPr>
-              <a:t>Click to open: Interactive Project Report</a:t>
-            </a:r>
-          </a:p>
-        </p:txBody>
-      </p:sp>
-      <p:sp>
-        <p:nvSpPr>
-          <p:cNvPr id="11" name="TextBox 10"/>
-          <p:cNvSpPr txBox="1"/>
-          <p:nvPr/>
-        </p:nvSpPr>
-        <p:spPr>
-          <a:xfrm>
-            <a:off x="6172200" y="5870448"/>
-            <a:ext cx="5440680" cy="365760"/>
-          </a:xfrm>
-          <a:prstGeom prst="rect">
-            <a:avLst/>
-          </a:prstGeom>
-          <a:noFill/>
-        </p:spPr>
-        <p:txBody>
-          <a:bodyPr wrap="square" anchor="t" lIns="45720" rIns="45720">
-            <a:spAutoFit/>
-          </a:bodyPr>
-          <a:lstStyle/>
-          <a:p>
-            <a:pPr>
-              <a:spcAft>
-                <a:spcPts val="600"/>
-              </a:spcAft>
-            </a:pPr>
-            <a:r>
-              <a:rPr sz="1200" b="0" i="0">
-                <a:solidFill>
-                  <a:srgbClr val="5E5E5E"/>
-                </a:solidFill>
-                <a:latin typeface="Calibri"/>
-              </a:rPr>
-              <a:t>Opens in any web browser; works without internet</a:t>
-            </a:r>
-          </a:p>
-        </p:txBody>
-      </p:sp>
-      <p:sp>
-        <p:nvSpPr>
-          <p:cNvPr id="12" name="TextBox 11"/>
+          <p:cNvPr id="8" name="TextBox 7"/>
           <p:cNvSpPr txBox="1"/>
           <p:nvPr/>
         </p:nvSpPr>
@@ -28482,7 +28238,7 @@
       </p:sp>
       <p:sp>
         <p:nvSpPr>
-          <p:cNvPr id="13" name="TextBox 12"/>
+          <p:cNvPr id="9" name="TextBox 8"/>
           <p:cNvSpPr txBox="1"/>
           <p:nvPr/>
         </p:nvSpPr>

</xml_diff>